<commit_message>
Replace the AAAR deck's spectra slide with FTIR/TOR vs filter loading
The dust-band slide overstated the case: filter by filter, Addis Si-O and
CH/OH-NH band ratios sit inside IMPROVE's range. Slide 7 now shows held-out
IMPROVE FTIR/TOR falling from about 1.0 to 0.8 as HIPS loading rises, with
the Addis-like filters on the same path and the Addis loading band beyond it.

Co-Authored-By: Claude Opus 5.5 <noreply@anthropic.com>
</commit_message>
<xml_diff>
--- a/deliverables/aaar_poster_2026/aaar_practice_2026-10-15.pptx
+++ b/deliverables/aaar_poster_2026/aaar_practice_2026-10-15.pptx
@@ -509,7 +509,7 @@
           <a:lstStyle/>
           <a:p>
             <a:r>
-              <a:t>SAY: Today I want to show you that a problem we first saw in Addis Ababa is not only an Ethiopia problem. First a bit of context on what the air in Addis is made of. Then the problem itself: FTIR elemental carbon in Addis correlates with an independent measurement but sits on the wrong scale. Then the twist: the same FTIR method works well on typical US filters, but not on the US filters that look most like Addis. Last, why: those samples are much more heavily loaded and contain more dust than what the calibration learned from.</a:t>
+              <a:t>SAY: Today I want to show you that a problem we first saw in Addis Ababa is not only an Ethiopia problem. First a bit of context on what the air in Addis is made of. Then the problem itself: FTIR elemental carbon in Addis correlates with an independent measurement but sits on the wrong scale. Then the twist: the same FTIR method works well on typical US filters, but not on the US filters that look most like Addis. Last, why: those samples are much more heavily loaded than what the calibration learned from, and FTIR under-reads more the heavier a filter gets.</a:t>
             </a:r>
           </a:p>
           <a:p/>
@@ -965,13 +965,13 @@
           <a:lstStyle/>
           <a:p>
             <a:r>
-              <a:t>SAY: Second, composition. These are the typical infrared spectra in the low-wavenumber region, US in grey and Addis by season in colour. Look at the band near 1035: that is silicon-oxygen, mineral dust. Addis has 1.4 to 2.6 times more of it than IMPROVE, depending on season, and it correlates with aluminium and silicon in the Addis chemistry. The sulfate band, by contrast, is about the same. So Addis samples are both heavier and dustier than what the calibration learned from.</a:t>
+              <a:t>SAY: This ties the last two slides together. Each point is one held-out US filter: how much EC is on it along the bottom, and FTIR divided by TOR up the side, where 1 means they agree. For typical loadings FTIR and TOR agree, a ratio of about 1.1. As filters get heavier the ratio drops below 1, to about 0.8 for the heaviest US filters, and the Addis-like ones in red follow the same path, about 0.9. The shaded band is where Addis filters sit: past the end of almost everything the calibration has seen. So the heavier the sample, the more FTIR under-reads, and Addis is the extreme case.</a:t>
             </a:r>
           </a:p>
           <a:p/>
           <a:p>
             <a:r>
-              <a:t>NOTES: Figure from the 9 Oct notebook (research/ftir_hips_chem/ann_followup_20261009.ipynb, section 4); medians of band-area-normalised spectra (an exception to 'no averages' because the point is the typical shape; the gallery shows the IQR). Si-O ~1035 cm⁻¹: Spearman ρ with Si 0.90, Al 0.92. The sharp peaks at 1153/1210 are PTFE filter residue (3.7× IMPROVE), separate from the dust hump. Not sulfate: the SO₄ ν3 band is no stronger than IMPROVE. Colours here are the notebook's, not the house palette [FIX before AAAR].</a:t>
+              <a:t>NOTES: Loading on x is from HIPS (Fabs / MAC 10 × volume), not TOR, so the ratio is not plotted against its own denominator. Same all-IMPROVE lot-251 spline calibration and held-out sites as slides 4 and 5. Filters below 1 µg are not shown and ratios above 2 are drawn at the top edge. At low loadings the ratio is above 1 mostly because of the small positive intercept (+0.02 µg/m³ ≈ 0.6 µg per IMPROVE filter); read the right-hand side. Binned medians, held-out IMPROVE: 2 to 8 µg 1.08, above 16 µg 0.80; Addis-like above 16 µg 0.86 (n 11, small). The Addis band is from HIPS, because Addis has no TOR: we cannot plot Addis points here. Composition, if asked: Addis spectra have about 2× the Si-O dust band (~1035 cm⁻¹) of a typical IMPROVE filter, and Kiremt CH peaks stand out more against OH/NH, but both stay inside IMPROVE's range filter by filter (about 2 % of Addis above IMPROVE p95). Loading is the clear outlier; composition is not on its own.</a:t>
             </a:r>
           </a:p>
         </p:txBody>
@@ -4556,14 +4556,14 @@
               </a:defRPr>
             </a:pPr>
             <a:r>
-              <a:t>Addis spectra also carry a strong silicate dust band that IMPROVE filters lack</a:t>
+              <a:t>FTIR under-reads more as filters get heavier, and Addis filters are heavier still</a:t>
             </a:r>
           </a:p>
         </p:txBody>
       </p:sp>
       <p:pic>
         <p:nvPicPr>
-          <p:cNvPr id="3" name="Picture 2" descr="f5_addis_vs_improve_spectra.png"/>
+          <p:cNvPr id="3" name="Picture 2" descr="f5_ratio_vs_loading.png"/>
           <p:cNvPicPr>
             <a:picLocks noChangeAspect="1"/>
           </p:cNvPicPr>
@@ -4577,8 +4577,8 @@
         </p:blipFill>
         <p:spPr>
           <a:xfrm>
-            <a:off x="518007" y="1143000"/>
-            <a:ext cx="11155680" cy="4056610"/>
+            <a:off x="715910" y="1143000"/>
+            <a:ext cx="10759873" cy="5486400"/>
           </a:xfrm>
           <a:prstGeom prst="rect">
             <a:avLst/>
@@ -4701,7 +4701,7 @@
               </a:defRPr>
             </a:pPr>
             <a:r>
-              <a:t>Addis filters are far more heavily loaded and dustier than the calibration set.</a:t>
+              <a:t>FTIR under-reads more as loading rises, and Addis filters are far more heavily loaded than the calibration set.</a:t>
             </a:r>
           </a:p>
           <a:p>

</xml_diff>

<commit_message>
Rebuild AAAR deck slides 6-7 around OC/EC
Slide 6 shows both ways Addis is extreme: ~9x the EC per filter and OC/EC
~0.7 vs IMPROVE's 5.5. Slide 7 replaces FTIR/TOR vs loading with FTIR/TOR
vs OC/EC: held-out IMPROVE reads ~0.7 of TOR below OC/EC 3 in every loading
band, so the earlier loading trend was mostly OC/EC.

Co-Authored-By: Claude Opus 5.5 <noreply@anthropic.com>
</commit_message>
<xml_diff>
--- a/deliverables/aaar_poster_2026/aaar_practice_2026-10-15.pptx
+++ b/deliverables/aaar_poster_2026/aaar_practice_2026-10-15.pptx
@@ -509,7 +509,7 @@
           <a:lstStyle/>
           <a:p>
             <a:r>
-              <a:t>SAY: Today I want to show you that a problem we first saw in Addis Ababa is not only an Ethiopia problem. First a bit of context on what the air in Addis is made of. Then the problem itself: FTIR elemental carbon in Addis correlates with an independent measurement but sits on the wrong scale. Then the twist: the same FTIR method works well on typical US filters, but not on the US filters that look most like Addis. Last, why: those samples are much more heavily loaded than what the calibration learned from, and FTIR under-reads more the heavier a filter gets.</a:t>
+              <a:t>SAY: Today I want to show you that a problem we first saw in Addis Ababa is not only an Ethiopia problem. First a bit of context on what the air in Addis is made of. Then the problem itself: FTIR elemental carbon in Addis correlates with an independent measurement but sits on the wrong scale. Then the twist: the same FTIR method works well on typical US filters, but not on the US filters that look most like Addis. Last, why: those samples are much heavier and much more soot-dominated than what the calibration learned from, and FTIR under-reads EC-rich filters.</a:t>
             </a:r>
           </a:p>
           <a:p/>
@@ -889,13 +889,13 @@
           <a:lstStyle/>
           <a:p>
             <a:r>
-              <a:t>SAY: Why would that happen? First, loading. This shows how much EC sits on each filter, on a log scale. Grey is the IMPROVE calibration pool, amber is Addis. The median Addis filter has about 9 times more EC on it than the median IMPROVE filter, and 76 percent of Addis filters are above IMPROVE's 99th percentile. The calibration has almost never seen filters like these.</a:t>
+              <a:t>SAY: Why would that happen? Addis filters are unusual in two ways. On the left, how much EC sits on each filter: the typical Addis filter carries about 9 times more than the typical US filter. On the right, the ratio of organic carbon to elemental carbon. US filters sit around 6; Addis sits around 0.7, lower than 99.6 percent of the US filters. So Addis samples are both heavier and much more soot-dominated than anything the calibration learned from.</a:t>
             </a:r>
           </a:p>
           <a:p/>
           <a:p>
             <a:r>
-              <a:t>NOTES: Per filter = HIPS Fabs / MAC 10 × sampled volume, so both networks are on the same footing (IMPROVE ~33 m³ per filter at 22 L/min, SPARTAN ~7 m³ at 5 L/min). In concentration the gap looks like ~41× because of the volume difference; per filter is the fair comparison for what the FTIR sees. Loading alone is not the whole story: analogs that cover the Addis loading range are still biased.</a:t>
+              <a:t>NOTES: Left: per filter = HIPS Fabs / MAC 10 × sampled volume, so both networks are on the same footing (IMPROVE ~33 m³ per filter at 22 L/min, SPARTAN ~7 m³ at 5 L/min); in concentration the gap looks like ~41×. 76 % of Addis filters are above IMPROVE's 99th percentile. Right: Addis has no TOR, so Addis OC/EC is SPARTAN OC (FTIR-derived) over SPARTAN BC (HIPS-based); IMPROVE is TOR OC/EC. The FTIR OC is partly circular, but OC would have to be about 3× higher for the Addis median to reach even IMPROVE's 5th percentile (2.1). Dashed lines are medians.</a:t>
             </a:r>
           </a:p>
         </p:txBody>
@@ -965,13 +965,13 @@
           <a:lstStyle/>
           <a:p>
             <a:r>
-              <a:t>SAY: This ties the last two slides together. Each point is one held-out US filter: how much EC is on it along the bottom, and FTIR divided by TOR up the side, where 1 means they agree. For typical loadings FTIR and TOR agree, a ratio of about 1.1. As filters get heavier the ratio drops below 1, to about 0.8 for the heaviest US filters, and the Addis-like ones in red follow the same path, about 0.9. The shaded band is where Addis filters sit: past the end of almost everything the calibration has seen. So the heavier the sample, the more FTIR under-reads, and Addis is the extreme case.</a:t>
+              <a:t>SAY: This connects the two. Each point is one held-out US filter: its OC/EC ratio along the bottom, and FTIR divided by TOR up the side, where 1 means they agree. For typical US filters FTIR and TOR agree, a ratio around 1.0. On the most EC-rich US filters, OC/EC below 3, FTIR reads only about 0.7 of TOR, and the Addis-like filters in red follow the same line. The shaded band is where Addis sits: further down the OC/EC scale than nearly any US filter. So the more soot-dominated the sample, the more FTIR under-reads, and Addis is the extreme case.</a:t>
             </a:r>
           </a:p>
           <a:p/>
           <a:p>
             <a:r>
-              <a:t>NOTES: Loading on x is from HIPS (Fabs / MAC 10 × volume), not TOR, so the ratio is not plotted against its own denominator. Same all-IMPROVE lot-251 spline calibration and held-out sites as slides 4 and 5. Filters below 1 µg are not shown and ratios above 2 are drawn at the top edge. At low loadings the ratio is above 1 mostly because of the small positive intercept (+0.02 µg/m³ ≈ 0.6 µg per IMPROVE filter); read the right-hand side. Binned medians, held-out IMPROVE: 2 to 8 µg 1.08, above 16 µg 0.80; Addis-like above 16 µg 0.86 (n 11, small). The Addis band is from HIPS, because Addis has no TOR: we cannot plot Addis points here. Composition, if asked: Addis spectra have about 2× the Si-O dust band (~1035 cm⁻¹) of a typical IMPROVE filter, and Kiremt CH peaks stand out more against OH/NH, but both stay inside IMPROVE's range filter by filter (about 2 % of Addis above IMPROVE p95). Loading is the clear outlier; composition is not on its own.</a:t>
+              <a:t>NOTES: Same all-IMPROVE lot-251 spline calibration and held-out sites as slides 4 and 5; ratios above 2 drawn at the top edge. Binned medians: OC/EC ≤ 3 0.68 (n 217), 4.5 to 8 1.02, &gt; 11 2.05. High-OC/EC filters read above 1 partly because they are the low-EC filters, where the small positive intercept matters. Not a loading effect in disguise: within every loading band the OC/EC ≤ 3 filters read lower (medians 0.59 to 0.78) than OC/EC &gt; 8; in a robust fit of log ratio on log loading and log OC/EC, OC/EC carries the effect (+0.57) and loading almost none (-0.09). Heavier US filters are also more EC-rich, which is why FTIR/TOR also drifts down with loading. Addis band uses OC (FTIR) / BC (HIPS), see slide 6; no Addis points because Addis has no TOR. Composition beyond OC/EC: Addis Si-O dust band ~2× typical IMPROVE but inside IMPROVE's range filter by filter.</a:t>
             </a:r>
           </a:p>
         </p:txBody>
@@ -4479,14 +4479,14 @@
               </a:defRPr>
             </a:pPr>
             <a:r>
-              <a:t>Addis filters carry about 9 times more EC per filter than a typical IMPROVE filter</a:t>
+              <a:t>Addis filters are extreme in two ways: far heavier and far more EC-rich than US filters</a:t>
             </a:r>
           </a:p>
         </p:txBody>
       </p:sp>
       <p:pic>
         <p:nvPicPr>
-          <p:cNvPr id="3" name="Picture 2" descr="f4_loading_per_filter.png"/>
+          <p:cNvPr id="3" name="Picture 2" descr="f4_addis_extremes.png"/>
           <p:cNvPicPr>
             <a:picLocks noChangeAspect="1"/>
           </p:cNvPicPr>
@@ -4501,7 +4501,7 @@
         <p:spPr>
           <a:xfrm>
             <a:off x="518007" y="1143000"/>
-            <a:ext cx="11155680" cy="4933443"/>
+            <a:ext cx="11155680" cy="4301898"/>
           </a:xfrm>
           <a:prstGeom prst="rect">
             <a:avLst/>
@@ -4556,14 +4556,14 @@
               </a:defRPr>
             </a:pPr>
             <a:r>
-              <a:t>FTIR under-reads more as filters get heavier, and Addis filters are heavier still</a:t>
+              <a:t>FTIR under-reads EC on EC-rich US filters, and Addis is more EC-rich than almost all of them</a:t>
             </a:r>
           </a:p>
         </p:txBody>
       </p:sp>
       <p:pic>
         <p:nvPicPr>
-          <p:cNvPr id="3" name="Picture 2" descr="f5_ratio_vs_loading.png"/>
+          <p:cNvPr id="3" name="Picture 2" descr="f5_ratio_vs_ocec.png"/>
           <p:cNvPicPr>
             <a:picLocks noChangeAspect="1"/>
           </p:cNvPicPr>
@@ -4701,7 +4701,7 @@
               </a:defRPr>
             </a:pPr>
             <a:r>
-              <a:t>FTIR under-reads more as loading rises, and Addis filters are far more heavily loaded than the calibration set.</a:t>
+              <a:t>FTIR under-reads EC-rich filters, and Addis filters are heavier and more EC-rich than almost any US filter.</a:t>
             </a:r>
           </a:p>
           <a:p>

</xml_diff>

<commit_message>
Add the all-site OC/EC continuum to the AAAR deck
Slide 7 ranks all 211 IMPROVE and 32 SPARTAN sites by median OC/EC, with EC
from HIPS absorption for both networks: Addis is 2nd of 243 and 31 of 32
SPARTAN sites sit below the median US site. Slide 8 now uses the same HIPS
OC/EC on x, so it no longer shares TOR EC with the FTIR/TOR ratio on y.
SPARTAN chemistry now comes from the public v3.1.4 release; the in-house
file had Addis OC about 2x lower. Loading is back on its own slide.

Co-Authored-By: Claude Opus 5.5 <noreply@anthropic.com>
</commit_message>
<xml_diff>
--- a/deliverables/aaar_poster_2026/aaar_practice_2026-10-15.pptx
+++ b/deliverables/aaar_poster_2026/aaar_practice_2026-10-15.pptx
@@ -13,6 +13,7 @@
     <p:sldId id="261" r:id="rId13"/>
     <p:sldId id="262" r:id="rId14"/>
     <p:sldId id="263" r:id="rId15"/>
+    <p:sldId id="264" r:id="rId16"/>
   </p:sldIdLst>
   <p:sldSz cx="12191695" cy="6858000" type="screen4x3"/>
   <p:notesSz cx="6858000" cy="9144000"/>
@@ -591,7 +592,7 @@
           <a:p/>
           <a:p>
             <a:r>
-              <a:t>NOTES: Medians of each component are stacked; medians do not add up exactly to the median PM2.5 mass (black tick), and unmeasured mass (water, other ions) is not shown. Organic matter is SPARTAN's FTIR-derived OM. Black carbon is the SPARTAN HIPS-based BC, not FTIR EC. Dust uses the IMPROVE soil formula (2.20 Al + 2.49 Si + 1.63 Ca + 2.42 Fe + 1.94 Ti). Season medians: see figures/f6_addis_chemistry_medians.csv. Boundary layer: ERA5 median daily BLH ~370-410 m in Kiremt vs 650-800 m in Dry; normalising by BLH is on the list, not done. Season names: 'Bega' for Dry is from one source; the literature mostly says Dry / Belg / Kiremt.</a:t>
+              <a:t>NOTES: Medians of each component are stacked; medians do not add up exactly to the median PM2.5 mass (black tick), and unmeasured mass (water, other ions) is not shown. Organic matter is SPARTAN's FTIR-derived OM. Black carbon is the SPARTAN HIPS-based BC, not FTIR EC. Dust uses the IMPROVE soil formula (2.20 Al + 2.49 Si + 1.63 Ca + 2.42 Fe + 1.94 Ti). Season medians: see figures/f7_addis_chemistry_medians.csv. Source: SPARTAN public release v3.1.4 (Aug 2026). Boundary layer: ERA5 median daily BLH ~370-410 m in Kiremt vs 650-800 m in Dry; normalising by BLH is on the list, not done. Season names: 'Bega' for Dry is from one source; the literature mostly says Dry / Belg / Kiremt.</a:t>
             </a:r>
           </a:p>
         </p:txBody>
@@ -889,13 +890,13 @@
           <a:lstStyle/>
           <a:p>
             <a:r>
-              <a:t>SAY: Why would that happen? Addis filters are unusual in two ways. On the left, how much EC sits on each filter: the typical Addis filter carries about 9 times more than the typical US filter. On the right, the ratio of organic carbon to elemental carbon. US filters sit around 6; Addis sits around 0.7, lower than 99.6 percent of the US filters. So Addis samples are both heavier and much more soot-dominated than anything the calibration learned from.</a:t>
+              <a:t>SAY: Why would that happen? First, loading. This shows how much EC sits on each filter, on a log scale. Grey is the IMPROVE calibration pool, amber is Addis. The median Addis filter has about 9 times more EC on it than the median IMPROVE filter, and 76 percent of Addis filters are above IMPROVE's 99th percentile. The calibration has almost never seen filters like these.</a:t>
             </a:r>
           </a:p>
           <a:p/>
           <a:p>
             <a:r>
-              <a:t>NOTES: Left: per filter = HIPS Fabs / MAC 10 × sampled volume, so both networks are on the same footing (IMPROVE ~33 m³ per filter at 22 L/min, SPARTAN ~7 m³ at 5 L/min); in concentration the gap looks like ~41×. 76 % of Addis filters are above IMPROVE's 99th percentile. Right: Addis has no TOR, so Addis OC/EC is SPARTAN OC (FTIR-derived) over SPARTAN BC (HIPS-based); IMPROVE is TOR OC/EC. The FTIR OC is partly circular, but OC would have to be about 3× higher for the Addis median to reach even IMPROVE's 5th percentile (2.1). Dashed lines are medians.</a:t>
+              <a:t>NOTES: Per filter = HIPS Fabs / MAC 10 × sampled volume, so both networks are on the same footing (IMPROVE ~33 m³ per filter at 22 L/min, SPARTAN ~7 m³ at 5 L/min). In concentration the gap looks like ~41× because of the volume difference; per filter is the fair comparison for what the FTIR sees. Loading is not the driver on its own (next two slides): at fixed loading, OC/EC still matters.</a:t>
             </a:r>
           </a:p>
         </p:txBody>
@@ -965,13 +966,13 @@
           <a:lstStyle/>
           <a:p>
             <a:r>
-              <a:t>SAY: This connects the two. Each point is one held-out US filter: its OC/EC ratio along the bottom, and FTIR divided by TOR up the side, where 1 means they agree. For typical US filters FTIR and TOR agree, a ratio around 1.0. On the most EC-rich US filters, OC/EC below 3, FTIR reads only about 0.7 of TOR, and the Addis-like filters in red follow the same line. The shaded band is where Addis sits: further down the OC/EC scale than nearly any US filter. So the more soot-dominated the sample, the more FTIR under-reads, and Addis is the extreme case.</a:t>
+              <a:t>SAY: Second, composition. Every site in both networks, ranked by its typical ratio of organic to elemental carbon. Grey dots are the 211 IMPROVE sites; purple stars are the 32 SPARTAN sites around the world. Addis, the big gold star, has an OC/EC of about 1.2, lower than every single US site. 31 of the 32 SPARTAN sites sit below the typical US site. So the US calibration network covers the organic-rich end well, and the soot-rich end, where much of the world lives, barely at all.</a:t>
             </a:r>
           </a:p>
           <a:p/>
           <a:p>
             <a:r>
-              <a:t>NOTES: Same all-IMPROVE lot-251 spline calibration and held-out sites as slides 4 and 5; ratios above 2 drawn at the top edge. Binned medians: OC/EC ≤ 3 0.68 (n 217), 4.5 to 8 1.02, &gt; 11 2.05. High-OC/EC filters read above 1 partly because they are the low-EC filters, where the small positive intercept matters. Not a loading effect in disguise: within every loading band the OC/EC ≤ 3 filters read lower (medians 0.59 to 0.78) than OC/EC &gt; 8; in a robust fit of log ratio on log loading and log OC/EC, OC/EC carries the effect (+0.57) and loading almost none (-0.09). Heavier US filters are also more EC-rich, which is why FTIR/TOR also drifts down with loading. Addis band uses OC (FTIR) / BC (HIPS), see slide 6; no Addis points because Addis has no TOR. Composition beyond OC/EC: Addis Si-O dust band ~2× typical IMPROVE but inside IMPROVE's range filter by filter.</a:t>
+              <a:t>NOTES: One EC definition for both networks so the ranking does not lean on FTIR EC: EC = HIPS absorption / MAC 10 (IMPROVE fAbs; SPARTAN 'BC PM2.5', HIPS, method 221). OC: IMPROVE thermal-optical; SPARTAN 'OC PM2.5' is FTIR (method 218): SPARTAN has no thermal carbon, so the earlier 'thermal' labels on this plot were wrong. Site medians with IQR; IMPROVE sites with &gt;= 50 filters (FED export, 1988-2025), SPARTAN &gt;= 10 (public release v3.1.4, Aug 2026). Addis ranks 2 of 243 sites; 7 SPARTAN sites sit below the lowest IMPROVE site (Abu Dhabi is lowest overall). The older in-house file had Addis OC about 2x lower than the current release; this slide uses the release. Full table: figures/f5_ocec_site_continuum.csv.</a:t>
             </a:r>
           </a:p>
         </p:txBody>
@@ -997,6 +998,82 @@
 </file>
 
 <file path=ppt/notesSlides/notesSlide8.xml><?xml version="1.0" encoding="utf-8"?>
+<p:notes xmlns:a="http://schemas.openxmlformats.org/drawingml/2006/main" xmlns:p="http://schemas.openxmlformats.org/presentationml/2006/main" xmlns:r="http://schemas.openxmlformats.org/officeDocument/2006/relationships">
+  <p:cSld>
+    <p:spTree>
+      <p:nvGrpSpPr>
+        <p:cNvPr id="1" name=""/>
+        <p:cNvGrpSpPr/>
+        <p:nvPr/>
+      </p:nvGrpSpPr>
+      <p:grpSpPr>
+        <a:xfrm>
+          <a:off x="0" y="0"/>
+          <a:ext cx="0" cy="0"/>
+          <a:chOff x="0" y="0"/>
+          <a:chExt cx="0" cy="0"/>
+        </a:xfrm>
+      </p:grpSpPr>
+      <p:sp>
+        <p:nvSpPr>
+          <p:cNvPr id="2" name="Slide Image Placeholder 1"/>
+          <p:cNvSpPr>
+            <a:spLocks noGrp="1"/>
+          </p:cNvSpPr>
+          <p:nvPr>
+            <p:ph type="sldImg" idx="2"/>
+          </p:nvPr>
+        </p:nvSpPr>
+        <p:spPr/>
+      </p:sp>
+      <p:sp>
+        <p:nvSpPr>
+          <p:cNvPr id="3" name="Notes Placeholder 2"/>
+          <p:cNvSpPr>
+            <a:spLocks noGrp="1"/>
+          </p:cNvSpPr>
+          <p:nvPr>
+            <p:ph type="body" idx="3" sz="quarter"/>
+          </p:nvPr>
+        </p:nvSpPr>
+        <p:spPr/>
+        <p:txBody>
+          <a:bodyPr/>
+          <a:lstStyle/>
+          <a:p>
+            <a:r>
+              <a:t>SAY: This connects the two. Each point is one held-out US filter: its OC/EC along the bottom, and FTIR divided by TOR up the side, where 1 means they agree. For typical US filters they agree, about 1.0. On the most EC-rich US filters, OC/EC below 2.5, FTIR reads only about 0.7 of TOR, and the Addis-like filters in red follow the same line. The shaded band is where Addis sits, at the far low end. So the more soot-dominated the sample, the more FTIR under-reads, and Addis is beyond the edge of the US data.</a:t>
+            </a:r>
+          </a:p>
+          <a:p/>
+          <a:p>
+            <a:r>
+              <a:t>NOTES: x uses the same OC/EC as slide 7 (EC from HIPS), so x and y do not share TOR EC in the denominator. Same all-IMPROVE lot-251 spline calibration and held-out sites as slides 4 and 5; ratios above 2 drawn at the top. Binned medians: OC/EC &lt;= 2.5 0.74 (n 161), 3.5 to 7 1.00, &gt; 10 1.40. High ratios at high OC/EC are partly the small positive intercept on low-EC filters. The OC/EC trend holds within most loading bands (it flattens above ~16 µg per filter, where n is small). TOR's OC/EC split can still couple OC and TOR EC (charring), so treat the slope of the trend as indicative. No Addis points: Addis has no TOR.</a:t>
+            </a:r>
+          </a:p>
+        </p:txBody>
+      </p:sp>
+      <p:sp>
+        <p:nvSpPr>
+          <p:cNvPr id="4" name="Slide Number Placeholder 3"/>
+          <p:cNvSpPr>
+            <a:spLocks noGrp="1"/>
+          </p:cNvSpPr>
+          <p:nvPr>
+            <p:ph type="sldNum" idx="5" sz="quarter"/>
+          </p:nvPr>
+        </p:nvSpPr>
+        <p:spPr/>
+      </p:sp>
+    </p:spTree>
+  </p:cSld>
+  <p:clrMapOvr>
+    <a:masterClrMapping/>
+  </p:clrMapOvr>
+</p:notes>
+</file>
+
+<file path=ppt/notesSlides/notesSlide9.xml><?xml version="1.0" encoding="utf-8"?>
 <p:notes xmlns:a="http://schemas.openxmlformats.org/drawingml/2006/main" xmlns:p="http://schemas.openxmlformats.org/presentationml/2006/main" xmlns:r="http://schemas.openxmlformats.org/officeDocument/2006/relationships">
   <p:cSld>
     <p:spTree>
@@ -4178,7 +4255,7 @@
       </p:sp>
       <p:pic>
         <p:nvPicPr>
-          <p:cNvPr id="3" name="Picture 2" descr="f6_addis_chemistry.png"/>
+          <p:cNvPr id="3" name="Picture 2" descr="f7_addis_chemistry.png"/>
           <p:cNvPicPr>
             <a:picLocks noChangeAspect="1"/>
           </p:cNvPicPr>
@@ -4479,14 +4556,14 @@
               </a:defRPr>
             </a:pPr>
             <a:r>
-              <a:t>Addis filters are extreme in two ways: far heavier and far more EC-rich than US filters</a:t>
+              <a:t>Addis filters carry about 9 times more EC per filter than a typical IMPROVE filter</a:t>
             </a:r>
           </a:p>
         </p:txBody>
       </p:sp>
       <p:pic>
         <p:nvPicPr>
-          <p:cNvPr id="3" name="Picture 2" descr="f4_addis_extremes.png"/>
+          <p:cNvPr id="3" name="Picture 2" descr="f4_loading_per_filter.png"/>
           <p:cNvPicPr>
             <a:picLocks noChangeAspect="1"/>
           </p:cNvPicPr>
@@ -4501,7 +4578,7 @@
         <p:spPr>
           <a:xfrm>
             <a:off x="518007" y="1143000"/>
-            <a:ext cx="11155680" cy="4301898"/>
+            <a:ext cx="11155680" cy="4933443"/>
           </a:xfrm>
           <a:prstGeom prst="rect">
             <a:avLst/>
@@ -4556,14 +4633,91 @@
               </a:defRPr>
             </a:pPr>
             <a:r>
-              <a:t>FTIR under-reads EC on EC-rich US filters, and Addis is more EC-rich than almost all of them</a:t>
+              <a:t>Addis is more EC-rich than every IMPROVE site, and 31 of 32 SPARTAN sites sit below the typical US site</a:t>
             </a:r>
           </a:p>
         </p:txBody>
       </p:sp>
       <p:pic>
         <p:nvPicPr>
-          <p:cNvPr id="3" name="Picture 2" descr="f5_ratio_vs_ocec.png"/>
+          <p:cNvPr id="3" name="Picture 2" descr="f5_ocec_site_continuum.png"/>
+          <p:cNvPicPr>
+            <a:picLocks noChangeAspect="1"/>
+          </p:cNvPicPr>
+          <p:nvPr/>
+        </p:nvPicPr>
+        <p:blipFill>
+          <a:blip r:embed="rId2"/>
+          <a:stretch>
+            <a:fillRect/>
+          </a:stretch>
+        </p:blipFill>
+        <p:spPr>
+          <a:xfrm>
+            <a:off x="518007" y="1143000"/>
+            <a:ext cx="11155680" cy="5054415"/>
+          </a:xfrm>
+          <a:prstGeom prst="rect">
+            <a:avLst/>
+          </a:prstGeom>
+        </p:spPr>
+      </p:pic>
+    </p:spTree>
+  </p:cSld>
+  <p:clrMapOvr>
+    <a:masterClrMapping/>
+  </p:clrMapOvr>
+</p:sld>
+</file>
+
+<file path=ppt/slides/slide8.xml><?xml version="1.0" encoding="utf-8"?>
+<p:sld xmlns:a="http://schemas.openxmlformats.org/drawingml/2006/main" xmlns:p="http://schemas.openxmlformats.org/presentationml/2006/main" xmlns:r="http://schemas.openxmlformats.org/officeDocument/2006/relationships">
+  <p:cSld>
+    <p:spTree>
+      <p:nvGrpSpPr>
+        <p:cNvPr id="1" name=""/>
+        <p:cNvGrpSpPr/>
+        <p:nvPr/>
+      </p:nvGrpSpPr>
+      <p:grpSpPr/>
+      <p:sp>
+        <p:nvSpPr>
+          <p:cNvPr id="2" name="TextBox 1"/>
+          <p:cNvSpPr txBox="1"/>
+          <p:nvPr/>
+        </p:nvSpPr>
+        <p:spPr>
+          <a:xfrm>
+            <a:off x="502920" y="320040"/>
+            <a:ext cx="11155680" cy="822960"/>
+          </a:xfrm>
+          <a:prstGeom prst="rect">
+            <a:avLst/>
+          </a:prstGeom>
+          <a:noFill/>
+        </p:spPr>
+        <p:txBody>
+          <a:bodyPr wrap="square">
+            <a:spAutoFit/>
+          </a:bodyPr>
+          <a:lstStyle/>
+          <a:p>
+            <a:pPr>
+              <a:defRPr sz="2000" b="1">
+                <a:solidFill>
+                  <a:srgbClr val="22252A"/>
+                </a:solidFill>
+              </a:defRPr>
+            </a:pPr>
+            <a:r>
+              <a:t>On US filters, FTIR under-reads EC as OC/EC falls, and Addis sits further down still</a:t>
+            </a:r>
+          </a:p>
+        </p:txBody>
+      </p:sp>
+      <p:pic>
+        <p:nvPicPr>
+          <p:cNvPr id="3" name="Picture 2" descr="f6_ratio_vs_ocec.png"/>
           <p:cNvPicPr>
             <a:picLocks noChangeAspect="1"/>
           </p:cNvPicPr>
@@ -4593,7 +4747,7 @@
 </p:sld>
 </file>
 
-<file path=ppt/slides/slide8.xml><?xml version="1.0" encoding="utf-8"?>
+<file path=ppt/slides/slide9.xml><?xml version="1.0" encoding="utf-8"?>
 <p:sld xmlns:a="http://schemas.openxmlformats.org/drawingml/2006/main" xmlns:p="http://schemas.openxmlformats.org/presentationml/2006/main" xmlns:r="http://schemas.openxmlformats.org/officeDocument/2006/relationships">
   <p:cSld>
     <p:spTree>

</xml_diff>

<commit_message>
Show the AAAR site continuum as OC/fAbs with every SPARTAN site named
Slide 7 now follows the fig08 OC/fAbs-by-site style: IMPROVE sites as grey
median ± IQR, each of the 32 SPARTAN sites as its own coloured star with its
value in the legend, Addis highlighted. Slide 8 uses the same OC/fAbs on x.
SPARTAN fAbs is 10 × its HIPS BC (checked on Addis, median ratio 10.00).

Co-Authored-By: Claude Opus 5.5 <noreply@anthropic.com>
</commit_message>
<xml_diff>
--- a/deliverables/aaar_poster_2026/aaar_practice_2026-10-15.pptx
+++ b/deliverables/aaar_poster_2026/aaar_practice_2026-10-15.pptx
@@ -966,13 +966,13 @@
           <a:lstStyle/>
           <a:p>
             <a:r>
-              <a:t>SAY: Second, composition. Every site in both networks, ranked by its typical ratio of organic to elemental carbon. Grey dots are the 211 IMPROVE sites; purple stars are the 32 SPARTAN sites around the world. Addis, the big gold star, has an OC/EC of about 1.2, lower than every single US site. 31 of the 32 SPARTAN sites sit below the typical US site. So the US calibration network covers the organic-rich end well, and the soot-rich end, where much of the world lives, barely at all.</a:t>
+              <a:t>SAY: Second, composition. Every site in both networks, ranked by how much organic carbon there is for each unit of light absorption by soot. Grey dots are the 211 US IMPROVE sites; each coloured star is one of the 32 SPARTAN sites around the world, listed in the legend. Addis, the big gold star, is at about 0.12, lower than every single US site, and 31 of the 32 SPARTAN sites sit below the typical US site. So the US calibration network covers the organic-rich end well, and the soot-rich end, where much of the world lives, barely at all.</a:t>
             </a:r>
           </a:p>
           <a:p/>
           <a:p>
             <a:r>
-              <a:t>NOTES: One EC definition for both networks so the ranking does not lean on FTIR EC: EC = HIPS absorption / MAC 10 (IMPROVE fAbs; SPARTAN 'BC PM2.5', HIPS, method 221). OC: IMPROVE thermal-optical; SPARTAN 'OC PM2.5' is FTIR (method 218): SPARTAN has no thermal carbon, so the earlier 'thermal' labels on this plot were wrong. Site medians with IQR; IMPROVE sites with &gt;= 50 filters (FED export, 1988-2025), SPARTAN &gt;= 10 (public release v3.1.4, Aug 2026). Addis ranks 2 of 243 sites; 7 SPARTAN sites sit below the lowest IMPROVE site (Abu Dhabi is lowest overall). The older in-house file had Addis OC about 2x lower than the current release; this slide uses the release. Full table: figures/f5_ocec_site_continuum.csv.</a:t>
+              <a:t>NOTES: OC/fAbs = OC (µg/m³) / HIPS absorption (Mm⁻¹); multiply by 10 for OC/EC at MAC 10. Using absorption avoids FTIR EC entirely. OC: IMPROVE thermal-optical; SPARTAN 'OC PM2.5' is FTIR (method 218), because SPARTAN has no thermal carbon (the earlier 'thermal' labels on the 4-site version were wrong). SPARTAN fAbs = 10 × 'BC PM2.5' (HIPS, method 221; checked against Addis HIPS, median ratio 10.00). Site medians with IQR; IMPROVE sites with &gt;= 50 filters (FED export, 1988-2025), SPARTAN &gt;= 10 (public release v3.1.4, Aug 2026). Addis ranks 2 of 243 sites; 7 SPARTAN sites sit below the lowest IMPROVE site; Abu Dhabi is lowest overall. The older in-house file had Addis OC about 2× lower; this uses the release. Table: figures/f5_ocfabs_site_continuum.csv.</a:t>
             </a:r>
           </a:p>
         </p:txBody>
@@ -1042,13 +1042,13 @@
           <a:lstStyle/>
           <a:p>
             <a:r>
-              <a:t>SAY: This connects the two. Each point is one held-out US filter: its OC/EC along the bottom, and FTIR divided by TOR up the side, where 1 means they agree. For typical US filters they agree, about 1.0. On the most EC-rich US filters, OC/EC below 2.5, FTIR reads only about 0.7 of TOR, and the Addis-like filters in red follow the same line. The shaded band is where Addis sits, at the far low end. So the more soot-dominated the sample, the more FTIR under-reads, and Addis is beyond the edge of the US data.</a:t>
+              <a:t>SAY: This connects the two. Each point is one held-out US filter: its OC per unit absorption along the bottom, the same measure as the last slide, and FTIR divided by TOR up the side, where 1 means they agree. For typical US filters they agree, about 1.0. On the most soot-rich US filters, below 0.25, FTIR reads only about 0.7 of TOR, and the Addis-like filters in red follow the same line. The shaded band is where Addis sits, at the far low end. So the more soot-dominated the sample, the more FTIR under-reads, and Addis is beyond the edge of the US data.</a:t>
             </a:r>
           </a:p>
           <a:p/>
           <a:p>
             <a:r>
-              <a:t>NOTES: x uses the same OC/EC as slide 7 (EC from HIPS), so x and y do not share TOR EC in the denominator. Same all-IMPROVE lot-251 spline calibration and held-out sites as slides 4 and 5; ratios above 2 drawn at the top. Binned medians: OC/EC &lt;= 2.5 0.74 (n 161), 3.5 to 7 1.00, &gt; 10 1.40. High ratios at high OC/EC are partly the small positive intercept on low-EC filters. The OC/EC trend holds within most loading bands (it flattens above ~16 µg per filter, where n is small). TOR's OC/EC split can still couple OC and TOR EC (charring), so treat the slope of the trend as indicative. No Addis points: Addis has no TOR.</a:t>
+              <a:t>NOTES: x = TOR OC / HIPS fAbs, the same measure as slide 7, so x and y do not share TOR EC in the denominator. Same all-IMPROVE lot-251 spline calibration and held-out sites as slides 4 and 5; ratios above 2 drawn at the top. Binned medians: OC/fAbs &lt;= 0.25 0.74 (n 161), 0.35 to 0.7 1.00, &gt; 1 1.40. High ratios at high OC/fAbs are partly the small positive intercept on low-EC filters. The trend holds within most loading bands (it flattens above ~16 µg per filter, where n is small). TOR's OC/EC split can still couple OC and TOR EC (charring), so treat the slope as indicative. No Addis points: Addis has no TOR.</a:t>
             </a:r>
           </a:p>
         </p:txBody>
@@ -4633,14 +4633,14 @@
               </a:defRPr>
             </a:pPr>
             <a:r>
-              <a:t>Addis is more EC-rich than every IMPROVE site, and 31 of 32 SPARTAN sites sit below the typical US site</a:t>
+              <a:t>Addis has less organic carbon per unit of soot absorption than every IMPROVE site; 31 of 32 SPARTAN sites sit below the typical US site</a:t>
             </a:r>
           </a:p>
         </p:txBody>
       </p:sp>
       <p:pic>
         <p:nvPicPr>
-          <p:cNvPr id="3" name="Picture 2" descr="f5_ocec_site_continuum.png"/>
+          <p:cNvPr id="3" name="Picture 2" descr="f5_ocfabs_site_continuum.png"/>
           <p:cNvPicPr>
             <a:picLocks noChangeAspect="1"/>
           </p:cNvPicPr>
@@ -4654,8 +4654,8 @@
         </p:blipFill>
         <p:spPr>
           <a:xfrm>
-            <a:off x="518007" y="1143000"/>
-            <a:ext cx="11155680" cy="5054415"/>
+            <a:off x="639362" y="1143000"/>
+            <a:ext cx="10912970" cy="5486400"/>
           </a:xfrm>
           <a:prstGeom prst="rect">
             <a:avLst/>
@@ -4710,14 +4710,14 @@
               </a:defRPr>
             </a:pPr>
             <a:r>
-              <a:t>On US filters, FTIR under-reads EC as OC/EC falls, and Addis sits further down still</a:t>
+              <a:t>On US filters, FTIR under-reads EC as OC per unit absorption falls, and Addis sits further down still</a:t>
             </a:r>
           </a:p>
         </p:txBody>
       </p:sp>
       <p:pic>
         <p:nvPicPr>
-          <p:cNvPr id="3" name="Picture 2" descr="f6_ratio_vs_ocec.png"/>
+          <p:cNvPr id="3" name="Picture 2" descr="f6_ratio_vs_ocfabs.png"/>
           <p:cNvPicPr>
             <a:picLocks noChangeAspect="1"/>
           </p:cNvPicPr>
@@ -4855,7 +4855,7 @@
               </a:defRPr>
             </a:pPr>
             <a:r>
-              <a:t>FTIR under-reads EC-rich filters, and Addis filters are heavier and more EC-rich than almost any US filter.</a:t>
+              <a:t>FTIR under-reads soot-rich filters, and Addis filters are heavier and more soot-rich than any US site.</a:t>
             </a:r>
           </a:p>
           <a:p>

</xml_diff>

<commit_message>
Rework the AAAR deck after Ann's 15 Oct review
Slide 2 now shows Addis EC by season against typical IMPROVE EC. OLS is
gone everywhere, "US" is now IMPROVE, and slide 5 puts HIPS on both x axes
with plain panel titles. The site continuum ranks EC from HIPS instead of
OC/fAbs, and the FTIR/TOR-vs-OC/fAbs slide is dropped. Three new slides:
baseline correction before/after (-6.1 to -1.1), the calibration explorer
for the spline baseline (bars, settings unnamed), and season-specific
calibrations (help in Kiremt only). The conclusions are rewritten.

Co-Authored-By: Claude Opus 5.5 <noreply@anthropic.com>
</commit_message>
<xml_diff>
--- a/deliverables/aaar_poster_2026/aaar_practice_2026-10-15.pptx
+++ b/deliverables/aaar_poster_2026/aaar_practice_2026-10-15.pptx
@@ -14,6 +14,8 @@
     <p:sldId id="262" r:id="rId14"/>
     <p:sldId id="263" r:id="rId15"/>
     <p:sldId id="264" r:id="rId16"/>
+    <p:sldId id="265" r:id="rId17"/>
+    <p:sldId id="266" r:id="rId18"/>
   </p:sldIdLst>
   <p:sldSz cx="12191695" cy="6858000" type="screen4x3"/>
   <p:notesSz cx="6858000" cy="9144000"/>
@@ -510,13 +512,165 @@
           <a:lstStyle/>
           <a:p>
             <a:r>
-              <a:t>SAY: Today I want to show you that a problem we first saw in Addis Ababa is not only an Ethiopia problem. First a bit of context on what the air in Addis is made of. Then the problem itself: FTIR elemental carbon in Addis correlates with an independent measurement but sits on the wrong scale. Then the twist: the same FTIR method works well on typical US filters, but not on the US filters that look most like Addis. Last, why: those samples are much heavier and much more soot-dominated than what the calibration learned from, and FTIR under-reads EC-rich filters.</a:t>
+              <a:t>SAY: This talk is about measuring elemental carbon, EC, in Addis Ababa, Ethiopia. First why we care: EC there is very high. Then the problem: the current FTIR calibration predicts Addis EC on the wrong scale, and the same calibration also struggles on the IMPROVE filters that look most like Addis. Then why: Addis filters carry far more EC than almost anything the calibration learned from. Then what we are doing about it: baseline correction, a calibration explorer to test thousands of calibrations, and season-specific calibrations.</a:t>
             </a:r>
           </a:p>
           <a:p/>
           <a:p>
             <a:r>
-              <a:t>NOTES: This is a practice run of the AAAR poster story, laid out as slides first (Ann's suggestion). PLS calibration-search material (specification curve, cohorts, VIBES baseline, k-sweep) is deliberately left out of the main slides; it is for discussion. Leave at least 20 minutes for questions.</a:t>
+              <a:t>NOTES: Practice run of the AAAR poster, laid out as slides first. Work in progress by design: the goal is feedback. Leave at least 20 minutes for questions; keep the first part of the discussion general.</a:t>
+            </a:r>
+          </a:p>
+        </p:txBody>
+      </p:sp>
+      <p:sp>
+        <p:nvSpPr>
+          <p:cNvPr id="4" name="Slide Number Placeholder 3"/>
+          <p:cNvSpPr>
+            <a:spLocks noGrp="1"/>
+          </p:cNvSpPr>
+          <p:nvPr>
+            <p:ph type="sldNum" idx="5" sz="quarter"/>
+          </p:nvPr>
+        </p:nvSpPr>
+        <p:spPr/>
+      </p:sp>
+    </p:spTree>
+  </p:cSld>
+  <p:clrMapOvr>
+    <a:masterClrMapping/>
+  </p:clrMapOvr>
+</p:notes>
+</file>
+
+<file path=ppt/notesSlides/notesSlide10.xml><?xml version="1.0" encoding="utf-8"?>
+<p:notes xmlns:a="http://schemas.openxmlformats.org/drawingml/2006/main" xmlns:p="http://schemas.openxmlformats.org/presentationml/2006/main" xmlns:r="http://schemas.openxmlformats.org/officeDocument/2006/relationships">
+  <p:cSld>
+    <p:spTree>
+      <p:nvGrpSpPr>
+        <p:cNvPr id="1" name=""/>
+        <p:cNvGrpSpPr/>
+        <p:nvPr/>
+      </p:nvGrpSpPr>
+      <p:grpSpPr>
+        <a:xfrm>
+          <a:off x="0" y="0"/>
+          <a:ext cx="0" cy="0"/>
+          <a:chOff x="0" y="0"/>
+          <a:chExt cx="0" cy="0"/>
+        </a:xfrm>
+      </p:grpSpPr>
+      <p:sp>
+        <p:nvSpPr>
+          <p:cNvPr id="2" name="Slide Image Placeholder 1"/>
+          <p:cNvSpPr>
+            <a:spLocks noGrp="1"/>
+          </p:cNvSpPr>
+          <p:nvPr>
+            <p:ph type="sldImg" idx="2"/>
+          </p:nvPr>
+        </p:nvSpPr>
+        <p:spPr/>
+      </p:sp>
+      <p:sp>
+        <p:nvSpPr>
+          <p:cNvPr id="3" name="Notes Placeholder 2"/>
+          <p:cNvSpPr>
+            <a:spLocks noGrp="1"/>
+          </p:cNvSpPr>
+          <p:nvPr>
+            <p:ph type="body" idx="3" sz="quarter"/>
+          </p:nvPr>
+        </p:nvSpPr>
+        <p:spPr/>
+        <p:txBody>
+          <a:bodyPr/>
+          <a:lstStyle/>
+          <a:p>
+            <a:r>
+              <a:t>SAY: One option we tried: a separate calibration for each Addis season, built from the IMPROVE filters whose spectra look most like that season. Grey is the single IMPROVE calibration from slide 8; colour is the season-specific one. In Kiremt the slope improves from 0.51 to 0.94 and R² from 0.52 to 0.68. In the dry season it barely changes, and in Belg it gets worse. So seasonality matters, and it is one of the levers we are exploring.</a:t>
+            </a:r>
+          </a:p>
+          <a:p/>
+          <a:p>
+            <a:r>
+              <a:t>NOTES: Each season: 500 IMPROVE spectral analogs (correlation, spectral region 600-3600 cm⁻¹ without CO₂ and the Teflon band), spline baseline, site-grouped calibration. Dry 0.28x -0.01 -&gt; 0.31x -0.08; Belg 0.48x -0.76 -&gt; 0.30x +1.12; Kiremt 0.51x -0.49 -&gt; 0.94x -0.59. Putting the three seasonal predictions together gives 1.43x -4.23 overall, because each season lands at a different offset.</a:t>
+            </a:r>
+          </a:p>
+        </p:txBody>
+      </p:sp>
+      <p:sp>
+        <p:nvSpPr>
+          <p:cNvPr id="4" name="Slide Number Placeholder 3"/>
+          <p:cNvSpPr>
+            <a:spLocks noGrp="1"/>
+          </p:cNvSpPr>
+          <p:nvPr>
+            <p:ph type="sldNum" idx="5" sz="quarter"/>
+          </p:nvPr>
+        </p:nvSpPr>
+        <p:spPr/>
+      </p:sp>
+    </p:spTree>
+  </p:cSld>
+  <p:clrMapOvr>
+    <a:masterClrMapping/>
+  </p:clrMapOvr>
+</p:notes>
+</file>
+
+<file path=ppt/notesSlides/notesSlide11.xml><?xml version="1.0" encoding="utf-8"?>
+<p:notes xmlns:a="http://schemas.openxmlformats.org/drawingml/2006/main" xmlns:p="http://schemas.openxmlformats.org/presentationml/2006/main" xmlns:r="http://schemas.openxmlformats.org/officeDocument/2006/relationships">
+  <p:cSld>
+    <p:spTree>
+      <p:nvGrpSpPr>
+        <p:cNvPr id="1" name=""/>
+        <p:cNvGrpSpPr/>
+        <p:nvPr/>
+      </p:nvGrpSpPr>
+      <p:grpSpPr>
+        <a:xfrm>
+          <a:off x="0" y="0"/>
+          <a:ext cx="0" cy="0"/>
+          <a:chOff x="0" y="0"/>
+          <a:chExt cx="0" cy="0"/>
+        </a:xfrm>
+      </p:grpSpPr>
+      <p:sp>
+        <p:nvSpPr>
+          <p:cNvPr id="2" name="Slide Image Placeholder 1"/>
+          <p:cNvSpPr>
+            <a:spLocks noGrp="1"/>
+          </p:cNvSpPr>
+          <p:nvPr>
+            <p:ph type="sldImg" idx="2"/>
+          </p:nvPr>
+        </p:nvSpPr>
+        <p:spPr/>
+      </p:sp>
+      <p:sp>
+        <p:nvSpPr>
+          <p:cNvPr id="3" name="Notes Placeholder 2"/>
+          <p:cNvSpPr>
+            <a:spLocks noGrp="1"/>
+          </p:cNvSpPr>
+          <p:nvPr>
+            <p:ph type="body" idx="3" sz="quarter"/>
+          </p:nvPr>
+        </p:nvSpPr>
+        <p:spPr/>
+        <p:txBody>
+          <a:bodyPr/>
+          <a:lstStyle/>
+          <a:p>
+            <a:r>
+              <a:t>SAY: To sum up. Addis has very high EC, and the calibrations built on IMPROVE do not predict it well, for Addis and for the IMPROVE filters that look like Addis. Addis filters are far heavier than what the calibration has seen. Baseline correction is a real improvement, season-specific calibrations help in one season, and we have a tool to test many more options. I would love your ideas on what to try next.</a:t>
+            </a:r>
+          </a:p>
+          <a:p/>
+          <a:p>
+            <a:r>
+              <a:t>NOTES: Open for discussion: VIBES baseline; the 14 Oct k-sweep (Addis intercept gets more negative with more PLS factors: spline -0.1 to -1.6, VIBES -0.3 to -7.0 µg/m³ at k 2 to 20); OC/fAbs by site (Addis lowest of the IMPROVE sites, a possible reason; not on a slide); boundary-layer normalisation; Chile sites after AAAR.</a:t>
             </a:r>
           </a:p>
         </p:txBody>
@@ -586,13 +740,13 @@
           <a:lstStyle/>
           <a:p>
             <a:r>
-              <a:t>SAY: This is what PM2.5 in Addis Ababa is made of, by season. Each bar is the median of each component. Ethiopia has three seasons: a long dry season, the short Belg rains, and the main Kiremt rainy season. Kiremt has the highest concentrations, partly because the boundary layer is shallow then, so pollution is trapped close to the ground. Organic matter and dust are big pieces, and black carbon is a few µg/m³, far above typical US rural levels. Keep that in mind: these are very different filters from what US networks see.</a:t>
+              <a:t>SAY: Addis Ababa has three seasons: a long dry season, the short Belg rains, and the main Kiremt rainy season. The grey bars are total PM2.5 and the coloured bars are elemental carbon, EC. Two things: the rainy Kiremt season has the worst air, and EC is very high in every season, around 4 to 6 µg/m³, against about 0.1 at a typical IMPROVE site, the dotted line. That is why we care about measuring EC well in Addis.</a:t>
             </a:r>
           </a:p>
           <a:p/>
           <a:p>
             <a:r>
-              <a:t>NOTES: Medians of each component are stacked; medians do not add up exactly to the median PM2.5 mass (black tick), and unmeasured mass (water, other ions) is not shown. Organic matter is SPARTAN's FTIR-derived OM. Black carbon is the SPARTAN HIPS-based BC, not FTIR EC. Dust uses the IMPROVE soil formula (2.20 Al + 2.49 Si + 1.63 Ca + 2.42 Fe + 1.94 Ti). Season medians: see figures/f7_addis_chemistry_medians.csv. Source: SPARTAN public release v3.1.4 (Aug 2026). Boundary layer: ERA5 median daily BLH ~370-410 m in Kiremt vs 650-800 m in Dry; normalising by BLH is on the list, not done. Season names: 'Bega' for Dry is from one source; the literature mostly says Dry / Belg / Kiremt.</a:t>
+              <a:t>NOTES: EC = SPARTAN 'BC PM2.5', which is HIPS absorption / 10 (checked on Addis: median ratio 10.00), the same definition as IMPROVE fAbs / 10 for the dotted line (median over all IMPROVE filters in the FED export). Medians with IQR; SPARTAN public release v3.1.4 (Aug 2026). Kiremt is partly worse because the boundary layer is shallow (ERA5 median ~370-410 m vs 650-800 m in Dry). Season names: Dry is also called Bega.</a:t>
             </a:r>
           </a:p>
         </p:txBody>
@@ -662,13 +816,13 @@
           <a:lstStyle/>
           <a:p>
             <a:r>
-              <a:t>SAY: Here is the problem. Each point is one Addis filter. Along the bottom is EC from HIPS, an optical absorption measurement. Up the side is EC from FTIR with the current SPARTAN calibration. The correlation is strong, R² 0.78, but the line has a slope of 2.3 and an intercept of -6 µg/m³. The lower-EC filters, mostly dry season, come out too low, and the high Kiremt filters come out too high. So FTIR sees the EC signal, but the calibration maps it onto the wrong scale.</a:t>
+              <a:t>SAY: Here is the problem. Each point is one Addis filter. Along the bottom is EC from HIPS, an optical absorption measurement. Up the side is EC from FTIR with the current SPARTAN calibration. They are well correlated, R² 0.78, but the line has a slope of 2.3 and an intercept of -6 µg/m³: lower-EC filters, mostly dry season, come out too low, and the high Kiremt filters too high.</a:t>
             </a:r>
           </a:p>
           <a:p/>
           <a:p>
             <a:r>
-              <a:t>NOTES: Deming regression, HIPS EC = Fabs / MAC 10 on x. The Deming intercept does not depend on MAC; slope does. Why HIPS and not TOR: SPARTAN filters have no thermal-optical TOR analysis, so HIPS is the independent reference at Addis. n 189 filters with both. Current SPARTAN calibration = the deployed network calibration (built on IMPROVE filters). Season colours: Dry amber, Belg purple, Kiremt blue. Expected question: 'is HIPS right?' HIPS and TOR agree on IMPROVE (next slides), including on the Addis-like filters.</a:t>
+              <a:t>NOTES: Deming regression, HIPS EC = Fabs / MAC 10 on x. SPARTAN filters have no thermal-optical (TOR) analysis, so HIPS is the independent reference at Addis. n 189. The current calibration uses spectra without baseline correction (slide 8). Colours are the three seasons from slide 2.</a:t>
             </a:r>
           </a:p>
         </p:txBody>
@@ -738,13 +892,13 @@
           <a:lstStyle/>
           <a:p>
             <a:r>
-              <a:t>SAY: Now the US. The IMPROVE network has both FTIR and the thermal reference method, TOR. We built the calibration on IMPROVE filters and tested it on filters from sites the calibration never saw. On these 2,078 held-out filters, FTIR matches TOR well: slope 0.93, intercept close to zero, R² 0.73. This is the established method working as intended.</a:t>
+              <a:t>SAY: Now IMPROVE, where filters have both FTIR and the thermal method, TOR. The calibration is built on IMPROVE filters and tested on filters from sites it never saw. On these 2,078 held-out filters, FTIR matches TOR well: slope 0.93, intercept close to zero, R² 0.73.</a:t>
             </a:r>
           </a:p>
           <a:p/>
           <a:p>
             <a:r>
-              <a:t>NOTES: Spline (AIRSpec) baseline-corrected spectra, all-IMPROVE calibration on lot 251, read out on held-out sites (site-disjoint split). Same baseline and calibration approach as the next slide; only the samples change. TOR vs HIPS on the same held-out filters: Deming 1.19x -0.02, R² 0.72. Axis clipped at 1.2 µg/m³ for readability; count of clipped points is printed on the figure. Units µg/m³; IMPROVE samples ~33 m³ per filter, SPARTAN ~7 m³, so concentrations understate the loading gap (slide 6).</a:t>
+              <a:t>NOTES: Baseline-corrected (spline, AIRSpec) spectra, all-IMPROVE calibration on lot 251, held-out sites. TOR vs HIPS on the same filters: 1.19x -0.02, R² 0.72. FTIR vs HIPS on the same filters: 0.88x +0.04, R² 0.47. Axis clipped at 1.2 µg/m³.</a:t>
             </a:r>
           </a:p>
         </p:txBody>
@@ -814,13 +968,13 @@
           <a:lstStyle/>
           <a:p>
             <a:r>
-              <a:t>SAY: Here is the key result. Out of the held-out US filters, we picked the 97 whose infrared spectra look most like Addis Ababa, in red. On the left, the two reference methods, TOR and HIPS, still agree on them: slope 0.91, R² 0.82. So the reference values are fine. On the right, FTIR reads only about half of TOR: slope 0.48, R² 0.46. For the analogs of the dry season it is worse, slope 0.44. Same calibration, same baseline. Only the samples changed. So the Addis problem also shows up inside the US network, for its most Addis-like filters.</a:t>
+              <a:t>SAY: Out of the held-out IMPROVE filters, we picked the 97 whose infrared spectra look most like Addis Ababa, in red; grey is all held-out IMPROVE. On the left, TOR and HIPS agree on them: slope 0.91, R² 0.82. On the right, FTIR EC against HIPS: slope 0.46 and R² 0.52. FTIR is too high at the low end and too low at the high end. Same calibration as the last slide; only the samples changed. So the Addis problem also shows up inside IMPROVE, for its most Addis-like filters.</a:t>
             </a:r>
           </a:p>
           <a:p/>
           <a:p>
             <a:r>
-              <a:t>NOTES: Analogs: the 500 IMPROVE filters whose spectra correlate best with the Addis spectra (Pearson r on the spline-corrected spectra); 97 of them come from held-out sites and are shown. All 97 are from the test split (88 lot 251, 9 lot 248), so none trained the calibration. Grey = all held-out IMPROVE for context. Deming fit drawn in red; OLS in the box. Caveat: 'most Addis-like' depends on the similarity metric and window; the spline and VIBES baselines choose mostly different analogs (shared of 500: Dry 31, Belg 128, Kiremt 166). Ann's self-prediction question: IMPROVE predicts IMPROVE well overall (slide 4) and the analogs fit well when they are themselves the calibration set (CV R² 0.5-0.9, bias ~0); the failure is transfer.</a:t>
+              <a:t>NOTES: Analogs: the 500 IMPROVE filters whose spectra correlate best with Addis; 97 are from held-out sites (88 lot 251, 9 lot 248) and none trained the calibration. Against TOR instead of HIPS: 0.48x +0.12, R² 0.46. Self-prediction: IMPROVE predicts IMPROVE well (slide 4), and the analogs fit well when they are themselves the calibration set (CV R² 0.5-0.9); the failure is transfer.</a:t>
             </a:r>
           </a:p>
         </p:txBody>
@@ -890,13 +1044,13 @@
           <a:lstStyle/>
           <a:p>
             <a:r>
-              <a:t>SAY: Why would that happen? First, loading. This shows how much EC sits on each filter, on a log scale. Grey is the IMPROVE calibration pool, amber is Addis. The median Addis filter has about 9 times more EC on it than the median IMPROVE filter, and 76 percent of Addis filters are above IMPROVE's 99th percentile. The calibration has almost never seen filters like these.</a:t>
+              <a:t>SAY: Why? This is how much EC sits on each filter, on a log scale: grey is the IMPROVE calibration pool, gold is Addis. The typical Addis filter has about 9 times more EC on it, and 76 percent of Addis filters are above IMPROVE's 99th percentile. The calibration has almost never seen filters like these.</a:t>
             </a:r>
           </a:p>
           <a:p/>
           <a:p>
             <a:r>
-              <a:t>NOTES: Per filter = HIPS Fabs / MAC 10 × sampled volume, so both networks are on the same footing (IMPROVE ~33 m³ per filter at 22 L/min, SPARTAN ~7 m³ at 5 L/min). In concentration the gap looks like ~41× because of the volume difference; per filter is the fair comparison for what the FTIR sees. Loading is not the driver on its own (next two slides): at fixed loading, OC/EC still matters.</a:t>
+              <a:t>NOTES: Per filter = HIPS Fabs / MAC 10 × sampled volume, so both networks are on the same footing (IMPROVE ~33 m³ per filter at 22 L/min, SPARTAN ~7 m³ at 5 L/min).</a:t>
             </a:r>
           </a:p>
         </p:txBody>
@@ -966,13 +1120,13 @@
           <a:lstStyle/>
           <a:p>
             <a:r>
-              <a:t>SAY: Second, composition. Every site in both networks, ranked by how much organic carbon there is for each unit of light absorption by soot. Grey dots are the 211 US IMPROVE sites; each coloured star is one of the 32 SPARTAN sites around the world, listed in the legend. Addis, the big gold star, is at about 0.12, lower than every single US site, and 31 of the 32 SPARTAN sites sit below the typical US site. So the US calibration network covers the organic-rich end well, and the soot-rich end, where much of the world lives, barely at all.</a:t>
+              <a:t>SAY: Every site in both networks, ranked by its typical EC. Grey dots are the 213 IMPROVE sites; each coloured star is one of the 36 SPARTAN sites around the world. Addis, the big gold star, is at about 4.7 µg/m³, above every IMPROVE site, and most SPARTAN sites sit at the high end. So this is not only Addis: the IMPROVE calibration network barely covers the EC levels much of the world lives with.</a:t>
             </a:r>
           </a:p>
           <a:p/>
           <a:p>
             <a:r>
-              <a:t>NOTES: OC/fAbs = OC (µg/m³) / HIPS absorption (Mm⁻¹); multiply by 10 for OC/EC at MAC 10. Using absorption avoids FTIR EC entirely. OC: IMPROVE thermal-optical; SPARTAN 'OC PM2.5' is FTIR (method 218), because SPARTAN has no thermal carbon (the earlier 'thermal' labels on the 4-site version were wrong). SPARTAN fAbs = 10 × 'BC PM2.5' (HIPS, method 221; checked against Addis HIPS, median ratio 10.00). Site medians with IQR; IMPROVE sites with &gt;= 50 filters (FED export, 1988-2025), SPARTAN &gt;= 10 (public release v3.1.4, Aug 2026). Addis ranks 2 of 243 sites; 7 SPARTAN sites sit below the lowest IMPROVE site; Abu Dhabi is lowest overall. The older in-house file had Addis OC about 2× lower; this uses the release. Table: figures/f5_ocfabs_site_continuum.csv.</a:t>
+              <a:t>NOTES: EC from HIPS for both networks (IMPROVE fAbs / 10, SPARTAN 'BC PM2.5' = fAbs / 10), so no FTIR EC is used. Site medians with IQR, log scale. IMPROVE sites with &gt;= 50 filters (FED export, 1988-2025); SPARTAN &gt;= 10 (public release v3.1.4). Addis is number 4 of 249 sites from the top; 21 SPARTAN sites are above the highest IMPROVE site (1.16 µg/m³). Concentration, not per-filter loading: per filter the SPARTAN values would be ~4.6x lower relative to IMPROVE. Table: figures/f5_ec_site_continuum.csv.</a:t>
             </a:r>
           </a:p>
         </p:txBody>
@@ -1042,13 +1196,13 @@
           <a:lstStyle/>
           <a:p>
             <a:r>
-              <a:t>SAY: This connects the two. Each point is one held-out US filter: its OC per unit absorption along the bottom, the same measure as the last slide, and FTIR divided by TOR up the side, where 1 means they agree. For typical US filters they agree, about 1.0. On the most soot-rich US filters, below 0.25, FTIR reads only about 0.7 of TOR, and the Addis-like filters in red follow the same line. The shaded band is where Addis sits, at the far low end. So the more soot-dominated the sample, the more FTIR under-reads, and Addis is beyond the edge of the US data.</a:t>
+              <a:t>SAY: What are we doing about it? The first thing we learned is that the spectra need baseline correction. On the left is the current calibration, without it. On the right, the same Addis filters predicted by a calibration built on baseline-corrected IMPROVE spectra. The intercept moves from -6.1 to -1.1 µg/m³. The slope drops to 0.56, so FTIR now reads low at high EC: better, but not solved.</a:t>
             </a:r>
           </a:p>
           <a:p/>
           <a:p>
             <a:r>
-              <a:t>NOTES: x = TOR OC / HIPS fAbs, the same measure as slide 7, so x and y do not share TOR EC in the denominator. Same all-IMPROVE lot-251 spline calibration and held-out sites as slides 4 and 5; ratios above 2 drawn at the top. Binned medians: OC/fAbs &lt;= 0.25 0.74 (n 161), 0.35 to 0.7 1.00, &gt; 1 1.40. High ratios at high OC/fAbs are partly the small positive intercept on low-EC filters. The trend holds within most loading bands (it flattens above ~16 µg per filter, where n is small). TOR's OC/EC split can still couple OC and TOR EC (charring), so treat the slope as indicative. No Addis points: Addis has no TOR.</a:t>
+              <a:t>NOTES: Left: current SPARTAN calibration, n 189. Right: spline (AIRSpec) baseline, all-IMPROVE lot-251 calibration, n 233, R² 0.67. The two calibrations differ in more than the baseline (training set and protocol too), so this is before/after for the approach, not a single-variable test. A second baseline method (VIBES) is being tested as well; it gives a more negative Addis intercept so far.</a:t>
             </a:r>
           </a:p>
         </p:txBody>
@@ -1118,13 +1272,13 @@
           <a:lstStyle/>
           <a:p>
             <a:r>
-              <a:t>SAY: To sum up. The established FTIR method works on the samples it was built from. It struggles on samples that look like Addis, and those exist inside the US network too, they are just rare, so whole-network validation never flags them. That matters for anyone using US-built calibrations in polluted, dusty, smoke-rich places, which is most of the Global South. Next we are working out which spectral features drive the shift and how to choose calibration samples that cover it.</a:t>
+              <a:t>SAY: Next, we built a tool that runs and compares many calibrations. Here are 3,138 of them, all on baseline-corrected spectra, ordered by how far off their Addis intercept is, from worst on the left to best on the right. The top line is that intercept; the current calibration is the red dashed line. Underneath, each row shows which calibrations used a choice: first, which IMPROVE filters to calibrate with, for example filters with the lowest OC/EC, or filters whose spectra look like each Addis season; second, the calibration settings. 3,137 of the 3,138 do better than the current calibration, and 254 get the intercept within half a microgram of zero, though not always with a good slope. We have not found a calibration that gets Addis right yet, but this is how we are searching.</a:t>
             </a:r>
           </a:p>
           <a:p/>
           <a:p>
             <a:r>
-              <a:t>NOTES: Open work, for discussion only: VIBES full-range baseline (more consistent on IMPROVE, worse Addis intercept); the 14 Oct k-sweep (Addis intercept falls as PLS factors increase: spline -0.1 to -1.6, VIBES -0.3 to -7.0 µg/m³ at k 2 to 20; smoke-like IMPROVE filters do not drift the same way); boundary-layer normalisation; Chile sites after AAAR.</a:t>
+              <a:t>NOTES: Spline baseline only (the VIBES baseline and no-baseline runs have their own versions of this plot). Deming intercept at MAC 10, median -1.4 µg/m³. Settings rows (A-E) are cross-validation scheme, number of PLS factors and cohort size; don't go into them. From the gallery export gallery/app/public/data/meeting-r70/spec_curve_20260917.json (rank-70 run).</a:t>
             </a:r>
           </a:p>
         </p:txBody>
@@ -4160,7 +4314,7 @@
               </a:defRPr>
             </a:pPr>
             <a:r>
-              <a:t>FTIR elemental carbon calibrated on US filters transfers poorly to heavily loaded, Ethiopia-like samples, in Addis Ababa and in the US network itself</a:t>
+              <a:t>FTIR elemental carbon calibrated on IMPROVE filters transfers poorly to heavily loaded samples like those in Addis Ababa, and to similar samples within IMPROVE</a:t>
             </a:r>
           </a:p>
         </p:txBody>
@@ -4196,6 +4350,234 @@
             </a:pPr>
             <a:r>
               <a:t>Ahmad Jalil, Ann M. Dillner, Satoshi Takahama  [FILL IN: affiliations, co-authors]</a:t>
+            </a:r>
+          </a:p>
+        </p:txBody>
+      </p:sp>
+    </p:spTree>
+  </p:cSld>
+  <p:clrMapOvr>
+    <a:masterClrMapping/>
+  </p:clrMapOvr>
+</p:sld>
+</file>
+
+<file path=ppt/slides/slide10.xml><?xml version="1.0" encoding="utf-8"?>
+<p:sld xmlns:a="http://schemas.openxmlformats.org/drawingml/2006/main" xmlns:p="http://schemas.openxmlformats.org/presentationml/2006/main" xmlns:r="http://schemas.openxmlformats.org/officeDocument/2006/relationships">
+  <p:cSld>
+    <p:spTree>
+      <p:nvGrpSpPr>
+        <p:cNvPr id="1" name=""/>
+        <p:cNvGrpSpPr/>
+        <p:nvPr/>
+      </p:nvGrpSpPr>
+      <p:grpSpPr/>
+      <p:sp>
+        <p:nvSpPr>
+          <p:cNvPr id="2" name="TextBox 1"/>
+          <p:cNvSpPr txBox="1"/>
+          <p:nvPr/>
+        </p:nvSpPr>
+        <p:spPr>
+          <a:xfrm>
+            <a:off x="502920" y="320040"/>
+            <a:ext cx="11155680" cy="822960"/>
+          </a:xfrm>
+          <a:prstGeom prst="rect">
+            <a:avLst/>
+          </a:prstGeom>
+          <a:noFill/>
+        </p:spPr>
+        <p:txBody>
+          <a:bodyPr wrap="square">
+            <a:spAutoFit/>
+          </a:bodyPr>
+          <a:lstStyle/>
+          <a:p>
+            <a:pPr>
+              <a:defRPr sz="2000" b="1">
+                <a:solidFill>
+                  <a:srgbClr val="22252A"/>
+                </a:solidFill>
+              </a:defRPr>
+            </a:pPr>
+            <a:r>
+              <a:t>Season-specific calibrations help in Kiremt, but not yet in the Dry or Belg seasons</a:t>
+            </a:r>
+          </a:p>
+        </p:txBody>
+      </p:sp>
+      <p:pic>
+        <p:nvPicPr>
+          <p:cNvPr id="3" name="Picture 2" descr="f8_seasonal_calibrations.png"/>
+          <p:cNvPicPr>
+            <a:picLocks noChangeAspect="1"/>
+          </p:cNvPicPr>
+          <p:nvPr/>
+        </p:nvPicPr>
+        <p:blipFill>
+          <a:blip r:embed="rId2"/>
+          <a:stretch>
+            <a:fillRect/>
+          </a:stretch>
+        </p:blipFill>
+        <p:spPr>
+          <a:xfrm>
+            <a:off x="518007" y="1143000"/>
+            <a:ext cx="11155680" cy="4063091"/>
+          </a:xfrm>
+          <a:prstGeom prst="rect">
+            <a:avLst/>
+          </a:prstGeom>
+        </p:spPr>
+      </p:pic>
+    </p:spTree>
+  </p:cSld>
+  <p:clrMapOvr>
+    <a:masterClrMapping/>
+  </p:clrMapOvr>
+</p:sld>
+</file>
+
+<file path=ppt/slides/slide11.xml><?xml version="1.0" encoding="utf-8"?>
+<p:sld xmlns:a="http://schemas.openxmlformats.org/drawingml/2006/main" xmlns:p="http://schemas.openxmlformats.org/presentationml/2006/main" xmlns:r="http://schemas.openxmlformats.org/officeDocument/2006/relationships">
+  <p:cSld>
+    <p:spTree>
+      <p:nvGrpSpPr>
+        <p:cNvPr id="1" name=""/>
+        <p:cNvGrpSpPr/>
+        <p:nvPr/>
+      </p:nvGrpSpPr>
+      <p:grpSpPr/>
+      <p:sp>
+        <p:nvSpPr>
+          <p:cNvPr id="2" name="TextBox 1"/>
+          <p:cNvSpPr txBox="1"/>
+          <p:nvPr/>
+        </p:nvSpPr>
+        <p:spPr>
+          <a:xfrm>
+            <a:off x="502920" y="320040"/>
+            <a:ext cx="11155680" cy="822960"/>
+          </a:xfrm>
+          <a:prstGeom prst="rect">
+            <a:avLst/>
+          </a:prstGeom>
+          <a:noFill/>
+        </p:spPr>
+        <p:txBody>
+          <a:bodyPr wrap="square">
+            <a:spAutoFit/>
+          </a:bodyPr>
+          <a:lstStyle/>
+          <a:p>
+            <a:pPr>
+              <a:defRPr sz="2000" b="1">
+                <a:solidFill>
+                  <a:srgbClr val="22252A"/>
+                </a:solidFill>
+              </a:defRPr>
+            </a:pPr>
+            <a:r>
+              <a:t>Conclusions</a:t>
+            </a:r>
+          </a:p>
+        </p:txBody>
+      </p:sp>
+      <p:sp>
+        <p:nvSpPr>
+          <p:cNvPr id="3" name="TextBox 2"/>
+          <p:cNvSpPr txBox="1"/>
+          <p:nvPr/>
+        </p:nvSpPr>
+        <p:spPr>
+          <a:xfrm>
+            <a:off x="822960" y="1554480"/>
+            <a:ext cx="10515600" cy="4572000"/>
+          </a:xfrm>
+          <a:prstGeom prst="rect">
+            <a:avLst/>
+          </a:prstGeom>
+          <a:noFill/>
+        </p:spPr>
+        <p:txBody>
+          <a:bodyPr wrap="square">
+            <a:spAutoFit/>
+          </a:bodyPr>
+          <a:lstStyle/>
+          <a:p>
+            <a:pPr>
+              <a:spcAft>
+                <a:spcPts val="1400"/>
+              </a:spcAft>
+              <a:defRPr sz="1600">
+                <a:solidFill>
+                  <a:srgbClr val="22252A"/>
+                </a:solidFill>
+              </a:defRPr>
+            </a:pPr>
+            <a:r>
+              <a:t>EC in Addis Ababa is very high, about 31× typical IMPROVE, and highest in the Kiremt rainy season.</a:t>
+            </a:r>
+          </a:p>
+          <a:p>
+            <a:pPr>
+              <a:spcAft>
+                <a:spcPts val="1400"/>
+              </a:spcAft>
+              <a:defRPr sz="1600">
+                <a:solidFill>
+                  <a:srgbClr val="22252A"/>
+                </a:solidFill>
+              </a:defRPr>
+            </a:pPr>
+            <a:r>
+              <a:t>Current FTIR calibrations poorly predict Addis EC, and also IMPROVE filters with Addis-like spectra.</a:t>
+            </a:r>
+          </a:p>
+          <a:p>
+            <a:pPr>
+              <a:spcAft>
+                <a:spcPts val="1400"/>
+              </a:spcAft>
+              <a:defRPr sz="1600">
+                <a:solidFill>
+                  <a:srgbClr val="22252A"/>
+                </a:solidFill>
+              </a:defRPr>
+            </a:pPr>
+            <a:r>
+              <a:t>Addis filters carry ~9× more EC than typical IMPROVE filters; most SPARTAN sites are also beyond IMPROVE.</a:t>
+            </a:r>
+          </a:p>
+          <a:p>
+            <a:pPr>
+              <a:spcAft>
+                <a:spcPts val="1400"/>
+              </a:spcAft>
+              <a:defRPr sz="1600">
+                <a:solidFill>
+                  <a:srgbClr val="22252A"/>
+                </a:solidFill>
+              </a:defRPr>
+            </a:pPr>
+            <a:r>
+              <a:t>Baseline correction helps: the Addis intercept goes from -6.1 to -1.1 µg/m³.</a:t>
+            </a:r>
+          </a:p>
+          <a:p>
+            <a:pPr>
+              <a:spcAft>
+                <a:spcPts val="1400"/>
+              </a:spcAft>
+              <a:defRPr sz="1600">
+                <a:solidFill>
+                  <a:srgbClr val="22252A"/>
+                </a:solidFill>
+              </a:defRPr>
+            </a:pPr>
+            <a:r>
+              <a:t>Season-specific calibrations help in Kiremt; a calibration explorer is helping us search for better ones.</a:t>
             </a:r>
           </a:p>
         </p:txBody>
@@ -4248,14 +4630,14 @@
               </a:defRPr>
             </a:pPr>
             <a:r>
-              <a:t>Addis Ababa PM2.5 peaks in the Kiremt rainy season; black carbon, organics and dust are each large shares</a:t>
+              <a:t>Elemental carbon in Addis Ababa is very high in every season, about 31× the typical IMPROVE level</a:t>
             </a:r>
           </a:p>
         </p:txBody>
       </p:sp>
       <p:pic>
         <p:nvPicPr>
-          <p:cNvPr id="3" name="Picture 2" descr="f7_addis_chemistry.png"/>
+          <p:cNvPr id="3" name="Picture 2" descr="f2b_addis_ec_by_season.png"/>
           <p:cNvPicPr>
             <a:picLocks noChangeAspect="1"/>
           </p:cNvPicPr>
@@ -4269,8 +4651,8 @@
         </p:blipFill>
         <p:spPr>
           <a:xfrm>
-            <a:off x="518007" y="1143000"/>
-            <a:ext cx="11155680" cy="4892728"/>
+            <a:off x="1124024" y="1143000"/>
+            <a:ext cx="9943647" cy="5486400"/>
           </a:xfrm>
           <a:prstGeom prst="rect">
             <a:avLst/>
@@ -4325,7 +4707,7 @@
               </a:defRPr>
             </a:pPr>
             <a:r>
-              <a:t>In Addis Ababa, FTIR EC tracks HIPS EC closely but on the wrong scale</a:t>
+              <a:t>In Addis Ababa, current SPARTAN FTIR EC is well correlated with HIPS EC but on the wrong scale</a:t>
             </a:r>
           </a:p>
         </p:txBody>
@@ -4402,7 +4784,7 @@
               </a:defRPr>
             </a:pPr>
             <a:r>
-              <a:t>On typical US filters the same FTIR method predicts EC well</a:t>
+              <a:t>On typical IMPROVE filters, the same FTIR method predicts EC well</a:t>
             </a:r>
           </a:p>
         </p:txBody>
@@ -4479,7 +4861,7 @@
               </a:defRPr>
             </a:pPr>
             <a:r>
-              <a:t>The same calibration under-reads the US filters whose spectra look most like Addis</a:t>
+              <a:t>Current calibrations poorly predict IMPROVE FTIR EC for spectra similar to Addis Ababa spectra</a:t>
             </a:r>
           </a:p>
         </p:txBody>
@@ -4633,14 +5015,14 @@
               </a:defRPr>
             </a:pPr>
             <a:r>
-              <a:t>Addis has less organic carbon per unit of soot absorption than every IMPROVE site; 31 of 32 SPARTAN sites sit below the typical US site</a:t>
+              <a:t>Addis Ababa EC is higher than at any IMPROVE site, and 35 of 36 SPARTAN sites sit above the typical IMPROVE site</a:t>
             </a:r>
           </a:p>
         </p:txBody>
       </p:sp>
       <p:pic>
         <p:nvPicPr>
-          <p:cNvPr id="3" name="Picture 2" descr="f5_ocfabs_site_continuum.png"/>
+          <p:cNvPr id="3" name="Picture 2" descr="f5_ec_site_continuum.png"/>
           <p:cNvPicPr>
             <a:picLocks noChangeAspect="1"/>
           </p:cNvPicPr>
@@ -4654,8 +5036,8 @@
         </p:blipFill>
         <p:spPr>
           <a:xfrm>
-            <a:off x="639362" y="1143000"/>
-            <a:ext cx="10912970" cy="5486400"/>
+            <a:off x="519702" y="1143000"/>
+            <a:ext cx="11152289" cy="5486400"/>
           </a:xfrm>
           <a:prstGeom prst="rect">
             <a:avLst/>
@@ -4710,14 +5092,14 @@
               </a:defRPr>
             </a:pPr>
             <a:r>
-              <a:t>On US filters, FTIR under-reads EC as OC per unit absorption falls, and Addis sits further down still</a:t>
+              <a:t>Baseline-correcting the spectra shrinks the Addis intercept from -6.1 to -1.1 µg/m³</a:t>
             </a:r>
           </a:p>
         </p:txBody>
       </p:sp>
       <p:pic>
         <p:nvPicPr>
-          <p:cNvPr id="3" name="Picture 2" descr="f6_ratio_vs_ocfabs.png"/>
+          <p:cNvPr id="3" name="Picture 2" descr="f6_baseline_before_after.png"/>
           <p:cNvPicPr>
             <a:picLocks noChangeAspect="1"/>
           </p:cNvPicPr>
@@ -4731,8 +5113,8 @@
         </p:blipFill>
         <p:spPr>
           <a:xfrm>
-            <a:off x="715910" y="1143000"/>
-            <a:ext cx="10759873" cy="5486400"/>
+            <a:off x="518007" y="1143000"/>
+            <a:ext cx="11155680" cy="5116645"/>
           </a:xfrm>
           <a:prstGeom prst="rect">
             <a:avLst/>
@@ -4787,94 +5169,35 @@
               </a:defRPr>
             </a:pPr>
             <a:r>
-              <a:t>Validating on the whole US network hides a calibration gap that matters for the Global South</a:t>
-            </a:r>
-          </a:p>
-        </p:txBody>
-      </p:sp>
-      <p:sp>
-        <p:nvSpPr>
-          <p:cNvPr id="3" name="TextBox 2"/>
-          <p:cNvSpPr txBox="1"/>
+              <a:t>A calibration explorer lets us evaluate thousands of calibrations to improve EC predictions</a:t>
+            </a:r>
+          </a:p>
+        </p:txBody>
+      </p:sp>
+      <p:pic>
+        <p:nvPicPr>
+          <p:cNvPr id="3" name="Picture 2" descr="f7_calibration_explorer.png"/>
+          <p:cNvPicPr>
+            <a:picLocks noChangeAspect="1"/>
+          </p:cNvPicPr>
           <p:nvPr/>
-        </p:nvSpPr>
+        </p:nvPicPr>
+        <p:blipFill>
+          <a:blip r:embed="rId2"/>
+          <a:stretch>
+            <a:fillRect/>
+          </a:stretch>
+        </p:blipFill>
         <p:spPr>
           <a:xfrm>
-            <a:off x="822960" y="1554480"/>
-            <a:ext cx="10515600" cy="4572000"/>
+            <a:off x="518007" y="1143000"/>
+            <a:ext cx="11155680" cy="4880295"/>
           </a:xfrm>
           <a:prstGeom prst="rect">
             <a:avLst/>
           </a:prstGeom>
-          <a:noFill/>
         </p:spPr>
-        <p:txBody>
-          <a:bodyPr wrap="square">
-            <a:spAutoFit/>
-          </a:bodyPr>
-          <a:lstStyle/>
-          <a:p>
-            <a:pPr>
-              <a:spcAft>
-                <a:spcPts val="1400"/>
-              </a:spcAft>
-              <a:defRPr sz="1700">
-                <a:solidFill>
-                  <a:srgbClr val="22252A"/>
-                </a:solidFill>
-              </a:defRPr>
-            </a:pPr>
-            <a:r>
-              <a:t>FTIR EC calibrated on IMPROVE works well on typical US filters.</a:t>
-            </a:r>
-          </a:p>
-          <a:p>
-            <a:pPr>
-              <a:spcAft>
-                <a:spcPts val="1400"/>
-              </a:spcAft>
-              <a:defRPr sz="1700">
-                <a:solidFill>
-                  <a:srgbClr val="22252A"/>
-                </a:solidFill>
-              </a:defRPr>
-            </a:pPr>
-            <a:r>
-              <a:t>It under-reads the US filters that look most like Addis Ababa, even though TOR and HIPS agree on them.</a:t>
-            </a:r>
-          </a:p>
-          <a:p>
-            <a:pPr>
-              <a:spcAft>
-                <a:spcPts val="1400"/>
-              </a:spcAft>
-              <a:defRPr sz="1700">
-                <a:solidFill>
-                  <a:srgbClr val="22252A"/>
-                </a:solidFill>
-              </a:defRPr>
-            </a:pPr>
-            <a:r>
-              <a:t>FTIR under-reads soot-rich filters, and Addis filters are heavier and more soot-rich than any US site.</a:t>
-            </a:r>
-          </a:p>
-          <a:p>
-            <a:pPr>
-              <a:spcAft>
-                <a:spcPts val="1400"/>
-              </a:spcAft>
-              <a:defRPr sz="1700">
-                <a:solidFill>
-                  <a:srgbClr val="22252A"/>
-                </a:solidFill>
-              </a:defRPr>
-            </a:pPr>
-            <a:r>
-              <a:t>So the Addis bias is a coverage problem that also exists inside the US network, not a quirk of one site.</a:t>
-            </a:r>
-          </a:p>
-        </p:txBody>
-      </p:sp>
+      </p:pic>
     </p:spTree>
   </p:cSld>
   <p:clrMapOvr>

</xml_diff>

<commit_message>
Use one 189-filter Addis cohort across the AAAR deck
Slides 2, 3, 6, 8 and 10 now all use the 189 Addis filters that have a
current SPARTAN FTIR EC value. Slides 8 and 10 used 233 before, so their
Deming fits are recomputed with the Addis lambda (3.335), which reproduces
the stored fits exactly. The explorer slide notes that it scored all 233.

Co-Authored-By: Claude Opus 5.5 <noreply@anthropic.com>
</commit_message>
<xml_diff>
--- a/deliverables/aaar_poster_2026/aaar_practice_2026-10-15.pptx
+++ b/deliverables/aaar_poster_2026/aaar_practice_2026-10-15.pptx
@@ -588,13 +588,13 @@
           <a:lstStyle/>
           <a:p>
             <a:r>
-              <a:t>SAY: One option we tried: a separate calibration for each Addis season, built from the IMPROVE filters whose spectra look most like that season. Grey is the single IMPROVE calibration from slide 8; colour is the season-specific one. In Kiremt the slope improves from 0.51 to 0.94 and R² from 0.52 to 0.68. In the dry season it barely changes, and in Belg it gets worse. So seasonality matters, and it is one of the levers we are exploring.</a:t>
+              <a:t>SAY: One option we tried: a separate calibration for each Addis season, built from the IMPROVE filters whose spectra look most like that season. Grey is the single IMPROVE calibration from slide 8; colour is the season-specific one. In Kiremt the slope improves from 0.50 to 0.94 and R² from 0.51 to 0.67. In the dry season it barely changes, and in Belg it gets worse. So seasonality matters, and it is one of the levers we are exploring.</a:t>
             </a:r>
           </a:p>
           <a:p/>
           <a:p>
             <a:r>
-              <a:t>NOTES: Each season: 500 IMPROVE spectral analogs (correlation, spectral region 600-3600 cm⁻¹ without CO₂ and the Teflon band), spline baseline, site-grouped calibration. Dry 0.28x -0.01 -&gt; 0.31x -0.08; Belg 0.48x -0.76 -&gt; 0.30x +1.12; Kiremt 0.51x -0.49 -&gt; 0.94x -0.59. Putting the three seasonal predictions together gives 1.43x -4.23 overall, because each season lands at a different offset.</a:t>
+              <a:t>NOTES: Each season: 500 IMPROVE spectral analogs (correlation, spectral region 600-3600 cm⁻¹ without CO₂ and the Teflon band), spline baseline, site-grouped calibration. Dry 0.31x -0.17 -&gt; 0.35x -0.29; Belg 0.49x -0.78 -&gt; 0.32x +1.06; Kiremt 0.50x -0.48 -&gt; 0.94x -0.57. Putting the three seasonal predictions together gives 1.51x -4.59 overall, because each season lands at a different offset. Same 189 Addis filters as slides 3 and 8.</a:t>
             </a:r>
           </a:p>
         </p:txBody>
@@ -746,7 +746,7 @@
           <a:p/>
           <a:p>
             <a:r>
-              <a:t>NOTES: EC = SPARTAN 'BC PM2.5', which is HIPS absorption / 10 (checked on Addis: median ratio 10.00), the same definition as IMPROVE fAbs / 10 for the dotted line (median over all IMPROVE filters in the FED export). Medians with IQR; SPARTAN public release v3.1.4 (Aug 2026). Kiremt is partly worse because the boundary layer is shallow (ERA5 median ~370-410 m vs 650-800 m in Dry). Season names: Dry is also called Bega.</a:t>
+              <a:t>NOTES: EC = SPARTAN 'BC PM2.5', which is HIPS absorption / 10 (checked on Addis: median ratio 10.00), the same definition as IMPROVE fAbs / 10 for the dotted line (median over all IMPROVE filters in the FED export). Medians with IQR over the same 189 Addis filters used on every Addis slide; SPARTAN public release v3.1.4 (Aug 2026). Kiremt is partly worse because the boundary layer is shallow (ERA5 median ~370-410 m vs 650-800 m in Dry). Season names: Dry is also called Bega.</a:t>
             </a:r>
           </a:p>
         </p:txBody>
@@ -1044,13 +1044,13 @@
           <a:lstStyle/>
           <a:p>
             <a:r>
-              <a:t>SAY: Why? This is how much EC sits on each filter, on a log scale: grey is the IMPROVE calibration pool, gold is Addis. The typical Addis filter has about 9 times more EC on it, and 76 percent of Addis filters are above IMPROVE's 99th percentile. The calibration has almost never seen filters like these.</a:t>
+              <a:t>SAY: Why? This is how much EC sits on each filter, on a log scale: grey is the IMPROVE calibration pool, gold is Addis. The typical Addis filter has about 9 times more EC on it, and 79 percent of Addis filters are above IMPROVE's 99th percentile. The calibration has almost never seen filters like these.</a:t>
             </a:r>
           </a:p>
           <a:p/>
           <a:p>
             <a:r>
-              <a:t>NOTES: Per filter = HIPS Fabs / MAC 10 × sampled volume, so both networks are on the same footing (IMPROVE ~33 m³ per filter at 22 L/min, SPARTAN ~7 m³ at 5 L/min).</a:t>
+              <a:t>NOTES: Per filter = HIPS Fabs / MAC 10 × sampled volume, so both networks are on the same footing (IMPROVE ~33 m³ per filter at 22 L/min, SPARTAN ~7 m³ at 5 L/min). Addis: the same 189 filters as slides 3, 8 and 10.</a:t>
             </a:r>
           </a:p>
         </p:txBody>
@@ -1126,7 +1126,7 @@
           <a:p/>
           <a:p>
             <a:r>
-              <a:t>NOTES: EC from HIPS for both networks (IMPROVE fAbs / 10, SPARTAN 'BC PM2.5' = fAbs / 10), so no FTIR EC is used. Site medians with IQR, log scale. IMPROVE sites with &gt;= 50 filters (FED export, 1988-2025); SPARTAN &gt;= 10 (public release v3.1.4). Addis is number 4 of 249 sites from the top; 21 SPARTAN sites are above the highest IMPROVE site (1.16 µg/m³). Concentration, not per-filter loading: per filter the SPARTAN values would be ~4.6x lower relative to IMPROVE. Table: figures/f5_ec_site_continuum.csv.</a:t>
+              <a:t>NOTES: EC from HIPS for both networks (IMPROVE fAbs / 10, SPARTAN 'BC PM2.5' = fAbs / 10), so no FTIR EC is used. Site medians with IQR, log scale; every site, Addis included, uses all its public filters (Addis n 246), so the comparison is like for like across sites. IMPROVE sites with &gt;= 50 filters (FED export, 1988-2025); SPARTAN &gt;= 10 (public release v3.1.4). Addis is number 4 of 249 sites from the top; 21 SPARTAN sites are above the highest IMPROVE site (1.16 µg/m³). Concentration, not per-filter loading: per filter the SPARTAN values would be ~4.6x lower relative to IMPROVE. Table: figures/f5_ec_site_continuum.csv.</a:t>
             </a:r>
           </a:p>
         </p:txBody>
@@ -1196,13 +1196,13 @@
           <a:lstStyle/>
           <a:p>
             <a:r>
-              <a:t>SAY: What are we doing about it? The first thing we learned is that the spectra need baseline correction. On the left is the current calibration, without it. On the right, the same Addis filters predicted by a calibration built on baseline-corrected IMPROVE spectra. The intercept moves from -6.1 to -1.1 µg/m³. The slope drops to 0.56, so FTIR now reads low at high EC: better, but not solved.</a:t>
+              <a:t>SAY: What are we doing about it? The first thing we learned is that the spectra need baseline correction. On the left is the current calibration, without it. On the right, the same Addis filters predicted by a calibration built on baseline-corrected IMPROVE spectra. The intercept moves from -6.1 to -1.2 µg/m³. The slope drops to 0.59, so FTIR now reads low at high EC: better, but not solved.</a:t>
             </a:r>
           </a:p>
           <a:p/>
           <a:p>
             <a:r>
-              <a:t>NOTES: Left: current SPARTAN calibration, n 189. Right: spline (AIRSpec) baseline, all-IMPROVE lot-251 calibration, n 233, R² 0.67. The two calibrations differ in more than the baseline (training set and protocol too), so this is before/after for the approach, not a single-variable test. A second baseline method (VIBES) is being tested as well; it gives a more negative Addis intercept so far.</a:t>
+              <a:t>NOTES: Both panels: the same 189 Addis filters (those with a current SPARTAN FTIR EC value). Right: spline (AIRSpec) baseline, all-IMPROVE lot-251 calibration, R² 0.69; on all 233 filters it is 0.56x -1.08. The two calibrations differ in more than the baseline (training set and protocol too), so this is before/after for the approach, not a single-variable test. A second baseline method (VIBES) is being tested as well; it gives a more negative Addis intercept so far.</a:t>
             </a:r>
           </a:p>
         </p:txBody>
@@ -1278,7 +1278,7 @@
           <a:p/>
           <a:p>
             <a:r>
-              <a:t>NOTES: Spline baseline only (the VIBES baseline and no-baseline runs have their own versions of this plot). Deming intercept at MAC 10, median -1.4 µg/m³. Settings rows (A-E) are cross-validation scheme, number of PLS factors and cohort size; don't go into them. From the gallery export gallery/app/public/data/meeting-r70/spec_curve_20260917.json (rank-70 run).</a:t>
+              <a:t>NOTES: Spline baseline only (the VIBES baseline and no-baseline runs have their own versions of this plot). Deming intercept at MAC 10, median -1.4 µg/m³. Settings rows (A-E) are cross-validation scheme, number of PLS factors and cohort size; don't go into them. The explorer scores all 233 Addis filters with HIPS (its stored grid has no per-filter predictions to re-score), while slides 3, 8 and 10 use the 189 that also have a current SPARTAN value. From the gallery export gallery/app/public/data/meeting-r70/spec_curve_20260917.json (rank-70 run).</a:t>
             </a:r>
           </a:p>
         </p:txBody>
@@ -4517,7 +4517,7 @@
               </a:defRPr>
             </a:pPr>
             <a:r>
-              <a:t>EC in Addis Ababa is very high, about 31× typical IMPROVE, and highest in the Kiremt rainy season.</a:t>
+              <a:t>EC in Addis Ababa is very high, about 32× typical IMPROVE, and highest in the Kiremt rainy season.</a:t>
             </a:r>
           </a:p>
           <a:p>
@@ -4562,7 +4562,7 @@
               </a:defRPr>
             </a:pPr>
             <a:r>
-              <a:t>Baseline correction helps: the Addis intercept goes from -6.1 to -1.1 µg/m³.</a:t>
+              <a:t>Baseline correction helps: the Addis intercept goes from -6.1 to -1.2 µg/m³.</a:t>
             </a:r>
           </a:p>
           <a:p>
@@ -4630,7 +4630,7 @@
               </a:defRPr>
             </a:pPr>
             <a:r>
-              <a:t>Elemental carbon in Addis Ababa is very high in every season, about 31× the typical IMPROVE level</a:t>
+              <a:t>Elemental carbon in Addis Ababa is very high in every season, about 32× the typical IMPROVE level</a:t>
             </a:r>
           </a:p>
         </p:txBody>
@@ -4651,8 +4651,8 @@
         </p:blipFill>
         <p:spPr>
           <a:xfrm>
-            <a:off x="1124024" y="1143000"/>
-            <a:ext cx="9943647" cy="5486400"/>
+            <a:off x="1130583" y="1143000"/>
+            <a:ext cx="9930528" cy="5486400"/>
           </a:xfrm>
           <a:prstGeom prst="rect">
             <a:avLst/>
@@ -5092,7 +5092,7 @@
               </a:defRPr>
             </a:pPr>
             <a:r>
-              <a:t>Baseline-correcting the spectra shrinks the Addis intercept from -6.1 to -1.1 µg/m³</a:t>
+              <a:t>Baseline-correcting the spectra shrinks the Addis intercept from -6.1 to -1.2 µg/m³</a:t>
             </a:r>
           </a:p>
         </p:txBody>

</xml_diff>

<commit_message>
AAAR deck: rank sites on HIPS-measured SPARTAN BC only
Public SPARTAN BC includes values estimated from the HIPS-SSR curve
(method 220) at many sites. Slide 7 now keeps HIPS measurements only, so 29
SPARTAN sites qualify; Addis is 2nd of 242 and 17 SPARTAN sites sit above
the highest IMPROVE site.

Co-Authored-By: Claude Opus 5.5 <noreply@anthropic.com>
</commit_message>
<xml_diff>
--- a/deliverables/aaar_poster_2026/aaar_practice_2026-10-15.pptx
+++ b/deliverables/aaar_poster_2026/aaar_practice_2026-10-15.pptx
@@ -1120,13 +1120,13 @@
           <a:lstStyle/>
           <a:p>
             <a:r>
-              <a:t>SAY: Every site in both networks, ranked by its typical EC. Grey dots are the 213 IMPROVE sites; each coloured star is one of the 36 SPARTAN sites around the world. Addis, the big gold star, is at about 4.7 µg/m³, above every IMPROVE site, and most SPARTAN sites sit at the high end. So this is not only Addis: the IMPROVE calibration network barely covers the EC levels much of the world lives with.</a:t>
+              <a:t>SAY: Every site in both networks, ranked by its typical EC. Grey dots are the 213 IMPROVE sites; each coloured star is one of the 29 SPARTAN sites around the world. Addis, the big gold star, is at about 4.7 µg/m³, above every IMPROVE site, and most SPARTAN sites sit at the high end. So this is not only Addis: the IMPROVE calibration network barely covers the EC levels much of the world lives with.</a:t>
             </a:r>
           </a:p>
           <a:p/>
           <a:p>
             <a:r>
-              <a:t>NOTES: EC from HIPS for both networks (IMPROVE fAbs / 10, SPARTAN 'BC PM2.5' = fAbs / 10), so no FTIR EC is used. Site medians with IQR, log scale; every site, Addis included, uses all its public filters (Addis n 246), so the comparison is like for like across sites. IMPROVE sites with &gt;= 50 filters (FED export, 1988-2025); SPARTAN &gt;= 10 (public release v3.1.4). Addis is number 4 of 249 sites from the top; 21 SPARTAN sites are above the highest IMPROVE site (1.16 µg/m³). Concentration, not per-filter loading: per filter the SPARTAN values would be ~4.6x lower relative to IMPROVE. Table: figures/f5_ec_site_continuum.csv.</a:t>
+              <a:t>NOTES: EC from HIPS for both networks (IMPROVE fAbs / 10, SPARTAN 'BC PM2.5' = fAbs / 10), so no FTIR EC is used. SPARTAN BC values estimated from the HIPS-SSR curve (method 220) are left out; only HIPS measurements count. Site medians with IQR, log scale; every site, Addis included, uses all its public filters (Addis n 246), so the comparison is like for like across sites. IMPROVE sites with &gt;= 50 filters (FED export, 1988-2025); SPARTAN &gt;= 10 (public release v3.1.4). Addis is number 2 of 242 sites from the top; 17 SPARTAN sites are above the highest IMPROVE site (1.16 µg/m³). Concentration, not per-filter loading: per filter the SPARTAN values would be ~4.6x lower relative to IMPROVE. Table: figures/f5_ec_site_continuum.csv.</a:t>
             </a:r>
           </a:p>
         </p:txBody>
@@ -5015,7 +5015,7 @@
               </a:defRPr>
             </a:pPr>
             <a:r>
-              <a:t>Addis Ababa EC is higher than at any IMPROVE site, and 35 of 36 SPARTAN sites sit above the typical IMPROVE site</a:t>
+              <a:t>Addis Ababa EC is higher than at any IMPROVE site, and 28 of 29 SPARTAN sites sit above the typical IMPROVE site</a:t>
             </a:r>
           </a:p>
         </p:txBody>
@@ -5036,8 +5036,8 @@
         </p:blipFill>
         <p:spPr>
           <a:xfrm>
-            <a:off x="519702" y="1143000"/>
-            <a:ext cx="11152289" cy="5486400"/>
+            <a:off x="579532" y="1143000"/>
+            <a:ext cx="11032629" cy="5486400"/>
           </a:xfrm>
           <a:prstGeom prst="rect">
             <a:avLst/>

</xml_diff>

<commit_message>
AAAR deck: name the calibration settings; label the seasonal fit lines
Slide 9 shows the setting names again (cross-validation scheme, PLS factor
counts, cohort size) instead of A-E. Slide 10 gets one shared legend for
the points, the two Deming fit lines (IMPROVE calibration in grey,
season-specific in the season colour) and the 1:1 line.

Co-Authored-By: Claude Opus 5.5 <noreply@anthropic.com>
</commit_message>
<xml_diff>
--- a/deliverables/aaar_poster_2026/aaar_practice_2026-10-15.pptx
+++ b/deliverables/aaar_poster_2026/aaar_practice_2026-10-15.pptx
@@ -588,7 +588,7 @@
           <a:lstStyle/>
           <a:p>
             <a:r>
-              <a:t>SAY: One option we tried: a separate calibration for each Addis season, built from the IMPROVE filters whose spectra look most like that season. Grey is the single IMPROVE calibration from slide 8; colour is the season-specific one. In Kiremt the slope improves from 0.50 to 0.94 and R² from 0.51 to 0.67. In the dry season it barely changes, and in Belg it gets worse. So seasonality matters, and it is one of the levers we are exploring.</a:t>
+              <a:t>SAY: One option we tried: a separate calibration for each Addis season, built from the IMPROVE filters whose spectra look most like that season. Grey points and the grey line are the single IMPROVE calibration from slide 8; coloured points and line are the season-specific one; the dotted line is 1:1. In Kiremt the slope improves from 0.50 to 0.94 and R² from 0.51 to 0.67. In the dry season it barely changes, and in Belg it gets worse. So seasonality matters, and it is one of the levers we are exploring.</a:t>
             </a:r>
           </a:p>
           <a:p/>
@@ -1278,7 +1278,7 @@
           <a:p/>
           <a:p>
             <a:r>
-              <a:t>NOTES: Spline baseline only (the VIBES baseline and no-baseline runs have their own versions of this plot). Deming intercept at MAC 10, median -1.4 µg/m³. Settings rows (A-E) are cross-validation scheme, number of PLS factors and cohort size; don't go into them. The explorer scores all 233 Addis filters with HIPS (its stored grid has no per-filter predictions to re-score), while slides 3, 8 and 10 use the 189 that also have a current SPARTAN value. From the gallery export gallery/app/public/data/meeting-r70/spec_curve_20260917.json (rank-70 run).</a:t>
+              <a:t>NOTES: Spline baseline only (the VIBES baseline and no-baseline runs have their own versions of this plot). Deming intercept at MAC 10, median -1.4 µg/m³. Settings rows: cross-validation scheme, number of PLS factors and cohort size; name them if asked, but don't go into them. The explorer scores all 233 Addis filters with HIPS (its stored grid has no per-filter predictions to re-score), while slides 3, 8 and 10 use the 189 that also have a current SPARTAN value. From the gallery export gallery/app/public/data/meeting-r70/spec_curve_20260917.json (rank-70 run).</a:t>
             </a:r>
           </a:p>
         </p:txBody>
@@ -4424,7 +4424,7 @@
         <p:spPr>
           <a:xfrm>
             <a:off x="518007" y="1143000"/>
-            <a:ext cx="11155680" cy="4063091"/>
+            <a:ext cx="11155680" cy="4139465"/>
           </a:xfrm>
           <a:prstGeom prst="rect">
             <a:avLst/>

</xml_diff>

<commit_message>
AAAR deck: authors and affiliations from the abstract
Co-Authored-By: Claude Opus 5.5 <noreply@anthropic.com>
</commit_message>
<xml_diff>
--- a/deliverables/aaar_poster_2026/aaar_practice_2026-10-15.pptx
+++ b/deliverables/aaar_poster_2026/aaar_practice_2026-10-15.pptx
@@ -4327,8 +4327,8 @@
         </p:nvSpPr>
         <p:spPr>
           <a:xfrm>
-            <a:off x="502920" y="4023360"/>
-            <a:ext cx="10972800" cy="1097280"/>
+            <a:off x="502920" y="3886200"/>
+            <a:ext cx="11155680" cy="2377440"/>
           </a:xfrm>
           <a:prstGeom prst="rect">
             <a:avLst/>
@@ -4336,20 +4336,83 @@
           <a:noFill/>
         </p:spPr>
         <p:txBody>
-          <a:bodyPr wrap="none">
+          <a:bodyPr wrap="square">
             <a:spAutoFit/>
           </a:bodyPr>
           <a:lstStyle/>
           <a:p>
             <a:pPr>
-              <a:defRPr sz="1600">
+              <a:spcAft>
+                <a:spcPts val="800"/>
+              </a:spcAft>
+              <a:defRPr sz="1600" b="1">
                 <a:solidFill>
-                  <a:srgbClr val="8F8C84"/>
+                  <a:srgbClr val="22252A"/>
                 </a:solidFill>
               </a:defRPr>
             </a:pPr>
             <a:r>
-              <a:t>Ahmad Jalil, Ann M. Dillner, Satoshi Takahama  [FILL IN: affiliations, co-authors]</a:t>
+              <a:t>Ahmad Jalil¹,⁴, Sina Hasheminassab², Kyan Shlipak⁵,², Tesfaye Mamo Mekonnen³, Araya Asfaw³, Hossein Kazemian¹, Ann M. Dillner⁴</a:t>
+            </a:r>
+          </a:p>
+          <a:p>
+            <a:pPr>
+              <a:defRPr sz="1200">
+                <a:solidFill>
+                  <a:srgbClr val="6E6B64"/>
+                </a:solidFill>
+              </a:defRPr>
+            </a:pPr>
+            <a:r>
+              <a:t>¹ Materials Technology &amp; Environmental Research (MATTER) lab, University of Northern British Columbia, Prince George, BC, Canada</a:t>
+            </a:r>
+          </a:p>
+          <a:p>
+            <a:pPr>
+              <a:defRPr sz="1200">
+                <a:solidFill>
+                  <a:srgbClr val="6E6B64"/>
+                </a:solidFill>
+              </a:defRPr>
+            </a:pPr>
+            <a:r>
+              <a:t>² NASA Jet Propulsion Laboratory, Pasadena, CA, USA</a:t>
+            </a:r>
+          </a:p>
+          <a:p>
+            <a:pPr>
+              <a:defRPr sz="1200">
+                <a:solidFill>
+                  <a:srgbClr val="6E6B64"/>
+                </a:solidFill>
+              </a:defRPr>
+            </a:pPr>
+            <a:r>
+              <a:t>³ Addis Ababa University, Addis Ababa, Ethiopia</a:t>
+            </a:r>
+          </a:p>
+          <a:p>
+            <a:pPr>
+              <a:defRPr sz="1200">
+                <a:solidFill>
+                  <a:srgbClr val="6E6B64"/>
+                </a:solidFill>
+              </a:defRPr>
+            </a:pPr>
+            <a:r>
+              <a:t>⁴ University of California Davis, Air Quality Research Center, Davis, CA, USA</a:t>
+            </a:r>
+          </a:p>
+          <a:p>
+            <a:pPr>
+              <a:defRPr sz="1200">
+                <a:solidFill>
+                  <a:srgbClr val="6E6B64"/>
+                </a:solidFill>
+              </a:defRPr>
+            </a:pPr>
+            <a:r>
+              <a:t>⁵ Northwestern University, Evanston, IL, USA</a:t>
             </a:r>
           </a:p>
         </p:txBody>

</xml_diff>

<commit_message>
AAAR poster: 15 Oct practice-talk feedback in the figures and notes
Seasonal EC bars with IMPROVE median and 95th percentile EC and median PM2.5,
in concentration and per filter; a histogram alternative to the cumulative
loading plot; plain-language axis titles; speaker notes that define terms, walk
the axes and answer "why IMPROVE"; open items (EC/mass selection, TOR OP).

Co-Authored-By: Claude Opus 5.5 <noreply@anthropic.com>
</commit_message>
<xml_diff>
--- a/deliverables/aaar_poster_2026/aaar_practice_2026-10-15.pptx
+++ b/deliverables/aaar_poster_2026/aaar_practice_2026-10-15.pptx
@@ -512,13 +512,13 @@
           <a:lstStyle/>
           <a:p>
             <a:r>
-              <a:t>SAY: This talk is about measuring elemental carbon, EC, in Addis Ababa, Ethiopia. First why we care: EC there is very high. Then the problem: the current FTIR calibration predicts Addis EC on the wrong scale, and the same calibration also struggles on the IMPROVE filters that look most like Addis. Then why: Addis filters carry far more EC than almost anything the calibration learned from. Then what we are doing about it: baseline correction, a calibration explorer to test thousands of calibrations, and season-specific calibrations.</a:t>
+              <a:t>SAY: This talk is about measuring elemental carbon in Addis Ababa, the capital of Ethiopia, a high-altitude city of about five million people. Elemental carbon, EC, is the black, soot-like part of fine particle pollution, mostly from burning. Organic carbon, OC, is the rest of the particle carbon, and organic matter, OM, is that carbon plus the hydrogen and oxygen attached to it. First why we care: EC in Addis is very high. Then the problem: the current FTIR calibration predicts Addis EC on the wrong scale, and the same calibration also struggles on the IMPROVE filters whose spectra most resemble Addis spectra. Then why: Addis filters carry far more EC than almost anything the calibration learned from. Then what we are doing about it: baseline correction of the spectra, a calibration explorer to test thousands of calibrations, and season-specific calibrations.</a:t>
             </a:r>
           </a:p>
           <a:p/>
           <a:p>
             <a:r>
-              <a:t>NOTES: Practice run of the AAAR poster, laid out as slides first. Work in progress by design: the goal is feedback. Leave at least 20 minutes for questions; keep the first part of the discussion general.</a:t>
+              <a:t>NOTES: Practice run of the AAAR poster, laid out as slides first. Work in progress by design: the goal is feedback. Leave at least 20 minutes for questions; keep the first part of the discussion general. Each later slide defines its terms the first time they come up; a full glossary is in talking_points.md.</a:t>
             </a:r>
           </a:p>
         </p:txBody>
@@ -588,7 +588,7 @@
           <a:lstStyle/>
           <a:p>
             <a:r>
-              <a:t>SAY: One option we tried: a separate calibration for each Addis season, built from the IMPROVE filters whose spectra look most like that season. Grey points and the grey line are the single IMPROVE calibration from slide 8; coloured points and line are the season-specific one; the dotted line is 1:1. In Kiremt the slope improves from 0.50 to 0.94 and R² from 0.51 to 0.67. In the dry season it barely changes, and in Belg it gets worse. So seasonality matters, and it is one of the levers we are exploring.</a:t>
+              <a:t>SAY: One option we tried: a separate calibration for each Addis season, built from the IMPROVE spectra that most resemble that season's Addis spectra (highest correlation across wavenumbers, excluding defined regions). Axes as before: HIPS EC along the bottom, FTIR-predicted EC up the side. Grey points and the grey line are the single IMPROVE calibration from slide 8; coloured points and line are the season-specific one; the dotted line is 1:1. In Kiremt the slope improves from 0.50 to 0.94 and R² from 0.51 to 0.67. In the dry season it barely changes, and in Belg it gets worse. So seasonality matters, and it is one of the levers we are exploring.</a:t>
             </a:r>
           </a:p>
           <a:p/>
@@ -664,13 +664,13 @@
           <a:lstStyle/>
           <a:p>
             <a:r>
-              <a:t>SAY: To sum up. Addis has very high EC, and the calibrations built on IMPROVE do not predict it well, for Addis and for the IMPROVE filters that look like Addis. Addis filters are far heavier than what the calibration has seen. Baseline correction is a real improvement, season-specific calibrations help in one season, and we have a tool to test many more options. I would love your ideas on what to try next.</a:t>
+              <a:t>SAY: To sum up. Addis has very high EC, and the calibrations built on IMPROVE do not predict it well, for Addis and for the IMPROVE filters whose spectra most resemble Addis. Addis filters are far heavier than what the calibration has seen. Baseline correction is a real improvement, season-specific calibrations help in one season, and we have a tool to test many more options. I would love your ideas on what to try next.</a:t>
             </a:r>
           </a:p>
           <a:p/>
           <a:p>
             <a:r>
-              <a:t>NOTES: Open for discussion: VIBES baseline; the 14 Oct k-sweep (Addis intercept gets more negative with more PLS factors: spline -0.1 to -1.6, VIBES -0.3 to -7.0 µg/m³ at k 2 to 20); OC/fAbs by site (Addis lowest of the IMPROVE sites, a possible reason; not on a slide); boundary-layer normalisation; Chile sites after AAAR.</a:t>
+              <a:t>NOTES: Open for discussion: VIBES baseline; the 14 Oct k-sweep (Addis intercept gets more negative with more PLS factors: spline -0.1 to -1.6, VIBES -0.3 to -7.0 µg/m³ at k 2 to 20); OC/fAbs by site (Addis lowest of the IMPROVE sites, a possible reason; not on a slide); boundary-layer normalisation; Chile sites after AAAR. From the 15 Oct practice talk (not run yet): EC-to-PM2.5 mass ratio as a calibration-set selection criterion; check TOR optical pyrolysis (OP) on fire-affected and Addis-like IMPROVE filters.</a:t>
             </a:r>
           </a:p>
         </p:txBody>
@@ -740,13 +740,13 @@
           <a:lstStyle/>
           <a:p>
             <a:r>
-              <a:t>SAY: Addis Ababa has three seasons: a long dry season, the short Belg rains, and the main Kiremt rainy season. The grey bars are total PM2.5 and the coloured bars are elemental carbon, EC. Two things: the rainy Kiremt season has the worst air, and EC is very high in every season, around 4 to 6 µg/m³, against about 0.1 at a typical IMPROVE site, the dotted line. That is why we care about measuring EC well in Addis.</a:t>
+              <a:t>SAY: Addis Ababa has three seasons: a long dry season, the short Belg rains, and the main Kiremt rainy season. The Addis filters come from SPARTAN, a global network of low-cost filter samplers in mostly urban, polluted places; we compare with IMPROVE, the US network that samples air in national parks and rural areas. Point at the axes first. On the left, up the side is concentration in the air, micrograms per cubic metre. The grey bars are total PM2.5, the fine particle mass, and the coloured bars are EC. EC here comes from HIPS, a measurement of how much light the filter absorbs. The three lines are IMPROVE references: the dotted line is typical IMPROVE EC, 0.15 µg/m³; the red dash-dot line is the IMPROVE 95th percentile, 0.64, so 95 percent of IMPROVE filters are below it; and the dashed line is typical IMPROVE PM2.5, 3.4. Addis EC is around 4 to 6 µg/m³ in every season, about 7 times even the 95th-percentile IMPROVE filter, and higher than typical IMPROVE PM2.5 as a whole. EC is also a much bigger share of the mass: about 19 to 25 percent of PM2.5 in Addis, against about 4 percent at a typical IMPROVE site. The rainy Kiremt season has the worst air. The right panel is the same thing as mass on the filter, which is what FTIR actually sees. IMPROVE pulls about 22 litres of air per minute through its filter, SPARTAN about 5, so an IMPROVE filter collects about four times more air. On the filter the EC gap shrinks from about 32 times to about 9 times, but Addis is still above the IMPROVE 95th percentile in every season. That is why we care about measuring EC well in Addis.</a:t>
             </a:r>
           </a:p>
           <a:p/>
           <a:p>
             <a:r>
-              <a:t>NOTES: EC = SPARTAN 'BC PM2.5', which is HIPS absorption / 10 (checked on Addis: median ratio 10.00), the same definition as IMPROVE fAbs / 10 for the dotted line (median over all IMPROVE filters in the FED export). Medians with IQR over the same 189 Addis filters used on every Addis slide; SPARTAN public release v3.1.4 (Aug 2026). Kiremt is partly worse because the boundary layer is shallow (ERA5 median ~370-410 m vs 650-800 m in Dry). Season names: Dry is also called Bega.</a:t>
+              <a:t>NOTES: EC = SPARTAN 'BC PM2.5', which is HIPS absorption / 10 (checked on Addis: median ratio 10.00), the same definition as IMPROVE fAbs / 10 for the reference lines. IMPROVE references over all 398,786 IMPROVE filters with fAbs in the FED export (2003 to 2025): EC median 0.149, 95th percentile 0.635, PM2.5 median 3.45 µg/m³ (IMPROVE gravimetric mass, MF, on the same Teflon filter). Per filter, IMPROVE EC is 1 to 11% of PM2.5 for the middle 90% of filters. Per-filter panel: IMPROVE volume = flow × sampling time where the export has both (159,414 filters; median 21.2 L/min, 30.5 m³), giving EC median 3.9 µg, 95th percentile 17.1 µg, PM2.5 median 91 µg per filter; Addis volumes from the evaluation table (median 7.3 m³). Medians with IQR over the 188 of the 189 Addis filters used on every Addis slide that have a public BC value; SPARTAN public release v3.1.4 (Aug 2026). Kiremt is partly worse because the boundary layer is shallow (ERA5 median ~370-410 m vs 650-800 m in Dry). Season names: Dry is also called Bega. To do: per-filter comparison ignores any difference in deposit area between the two samplers; check before quoting areal loading (µg/cm²).</a:t>
             </a:r>
           </a:p>
         </p:txBody>
@@ -816,13 +816,13 @@
           <a:lstStyle/>
           <a:p>
             <a:r>
-              <a:t>SAY: Here is the problem. Each point is one Addis filter. Along the bottom is EC from HIPS, an optical absorption measurement. Up the side is EC from FTIR with the current SPARTAN calibration. They are well correlated, R² 0.78, but the line has a slope of 2.3 and an intercept of -6 µg/m³: lower-EC filters, mostly dry season, come out too low, and the high Kiremt filters too high.</a:t>
+              <a:t>SAY: Here is the problem. Point at the axes first. Along the bottom is EC from HIPS: HIPS measures how much light the filter absorbs, Fabs, and we turn that into EC by dividing by the mass absorption cross-section, MAC, which is how strongly one gram of EC absorbs light; we use 10 square metres per gram. Up the side is EC predicted from the FTIR spectrum with the current SPARTAN calibration. FTIR is infrared spectroscopy: infrared light goes through the filter and we record how much is absorbed at each wavenumber; that curve is the spectrum. A PLS model, partial least squares, a standard regression method for spectra, learns from a calibration set, here IMPROVE filters whose EC was measured in the lab by TOR, how to turn a spectrum into EC. Each point is one Addis filter. R² is 0.78, so the two measurements are clearly related. But the slope of 2.3 and the intercept of -6 µg/m³ are not physically sensible: a filter with no EC on it would be predicted at about -6. Lower-EC filters, mostly dry season, come out too low, and the high Kiremt filters too high. And it is not just the MAC: changing the MAC stretches the bottom axis, which changes the slope, not the intercept.</a:t>
             </a:r>
           </a:p>
           <a:p/>
           <a:p>
             <a:r>
-              <a:t>NOTES: Deming regression, HIPS EC = Fabs / MAC 10 on x. SPARTAN filters have no thermal-optical (TOR) analysis, so HIPS is the independent reference at Addis. n 189. The current calibration uses spectra without baseline correction (slide 8). Colours are the three seasons from slide 2.</a:t>
+              <a:t>NOTES: Deming regression, HIPS EC = Fabs / MAC 10 on x. SPARTAN filters have no thermal-optical (TOR) analysis, so HIPS is the independent reference at Addis. n 189. The current calibration uses spectra without baseline correction (slide 8). Colours are the three seasons from slide 2. MAC check (Deming with the HIPS error rescaled with the axis): MAC 6 gives 1.38x -6.09, MAC 14 gives 3.22x -6.09; the intercept does not move. (If the Deming error ratio is held fixed instead, the intercept drifts a little, -5.4 to -6.5, but stays strongly negative.)</a:t>
             </a:r>
           </a:p>
         </p:txBody>
@@ -892,13 +892,13 @@
           <a:lstStyle/>
           <a:p>
             <a:r>
-              <a:t>SAY: Now IMPROVE, where filters have both FTIR and the thermal method, TOR. The calibration is built on IMPROVE filters and tested on filters from sites it never saw. On these 2,078 held-out filters, FTIR matches TOR well: slope 0.93, intercept close to zero, R² 0.73.</a:t>
+              <a:t>SAY: Now IMPROVE. Point at the axes first: along the bottom is EC from TOR, thermal-optical reflectance, the standard lab method that heats a punch of a quartz-fibre filter and measures the carbon that comes off; up the side is EC predicted from the FTIR spectrum. IMPROVE collects a Teflon filter for FTIR and a quartz filter for TOR from the same air at the same time, which is why every FTIR EC calibration is built on IMPROVE. Here the calibration is built on IMPROVE filters and tested on filters from sites it never saw. On these 2,078 held-out filters, FTIR matches TOR well: slope 0.93, intercept close to zero, R² 0.73.</a:t>
             </a:r>
           </a:p>
           <a:p/>
           <a:p>
             <a:r>
-              <a:t>NOTES: Baseline-corrected (spline, AIRSpec) spectra, all-IMPROVE calibration on lot 251, held-out sites. TOR vs HIPS on the same filters: 1.19x -0.02, R² 0.72. FTIR vs HIPS on the same filters: 0.88x +0.04, R² 0.47. Axis clipped at 1.2 µg/m³.</a:t>
+              <a:t>NOTES: Why calibrate with IMPROVE? (likely question) IMPROVE's collocated FTIR + TOR quartz library is the only one that exists anywhere; there is no Addis or urban equivalent, and CSN (the US urban network) filters are different (bigger, thicker, lower flow), so they cannot simply be added. Baseline-corrected (spline, AIRSpec) spectra, all-IMPROVE calibration on lot 251, held-out sites. TOR vs HIPS on the same filters: 1.19x -0.02, R² 0.72. FTIR vs HIPS on the same filters: 0.88x +0.04, R² 0.47. Axis clipped at 1.2 µg/m³.</a:t>
             </a:r>
           </a:p>
         </p:txBody>
@@ -968,13 +968,13 @@
           <a:lstStyle/>
           <a:p>
             <a:r>
-              <a:t>SAY: Out of the held-out IMPROVE filters, we picked the 97 whose infrared spectra look most like Addis Ababa, in red; grey is all held-out IMPROVE. On the left, TOR and HIPS agree on them: slope 0.91, R² 0.82. On the right, FTIR EC against HIPS: slope 0.46 and R² 0.52. FTIR is too high at the low end and too low at the high end. Same calibration as the last slide; only the samples changed. So the Addis problem also shows up inside IMPROVE, for its most Addis-like filters.</a:t>
+              <a:t>SAY: Out of the held-out IMPROVE filters, we picked 97 from the IMPROVE spectra that most resemble Addis spectra (highest correlation across wavenumbers, excluding defined regions such as the CO₂ band), in red; grey is all held-out IMPROVE. Point at the axes first: both panels have HIPS EC along the bottom; up the side is TOR EC on the left and FTIR-predicted EC on the right. On the left, TOR and HIPS agree on them: slope 0.91, R² 0.82. On the right, FTIR EC against HIPS: slope 0.46 and R² 0.52. FTIR is too high at the low end and too low at the high end. Same calibration as the last slide; only the samples changed. So the Addis problem also shows up inside IMPROVE, for the IMPROVE filters whose spectra most resemble Addis spectra.</a:t>
             </a:r>
           </a:p>
           <a:p/>
           <a:p>
             <a:r>
-              <a:t>NOTES: Analogs: the 500 IMPROVE filters whose spectra correlate best with Addis; 97 are from held-out sites (88 lot 251, 9 lot 248) and none trained the calibration. Against TOR instead of HIPS: 0.48x +0.12, R² 0.46. Self-prediction: IMPROVE predicts IMPROVE well (slide 4), and the analogs fit well when they are themselves the calibration set (CV R² 0.5-0.9); the failure is transfer.</a:t>
+              <a:t>NOTES: Analogs: the 500 IMPROVE filters whose spectra correlate best with the Addis median spectrum (Pearson correlation across wavenumbers, CO₂ region masked); 97 are from held-out sites (88 lot 251, 9 lot 248) and none trained the calibration. Against TOR instead of HIPS: 0.48x +0.12, R² 0.46. Self-prediction: IMPROVE predicts IMPROVE well (slide 4), and the analogs fit well when they are themselves the calibration set (CV R² 0.5-0.9); the failure is transfer.</a:t>
             </a:r>
           </a:p>
         </p:txBody>
@@ -1044,13 +1044,13 @@
           <a:lstStyle/>
           <a:p>
             <a:r>
-              <a:t>SAY: Why? This is how much EC sits on each filter, on a log scale: grey is the IMPROVE calibration pool, gold is Addis. The typical Addis filter has about 9 times more EC on it, and 79 percent of Addis filters are above IMPROVE's 99th percentile. The calibration has almost never seen filters like these.</a:t>
+              <a:t>SAY: Why? Point at the axes first. Along the bottom is how much EC sits on one filter, in micrograms, on a log scale, so each labelled tick is ten times the one before. Up the side is the percent of filters at that loading; each network adds up to 100 percent, so the small Addis set and the large IMPROVE set can share one plot. Grey is the IMPROVE filters the calibration learned from, gold is Addis. The two humps barely overlap. The dashed lines are the medians: the typical Addis filter has about 9 times more EC on it. The dotted line is IMPROVE's 99th percentile, and 79 percent of Addis filters are to the right of it. The calibration has almost never seen filters like these.</a:t>
             </a:r>
           </a:p>
           <a:p/>
           <a:p>
             <a:r>
-              <a:t>NOTES: Per filter = HIPS Fabs / MAC 10 × sampled volume, so both networks are on the same footing (IMPROVE ~33 m³ per filter at 22 L/min, SPARTAN ~7 m³ at 5 L/min). Addis: the same 189 filters as slides 3, 8 and 10.</a:t>
+              <a:t>NOTES: Per filter = HIPS Fabs / MAC 10 × sampled volume, so both networks are on the same footing (IMPROVE ~33 m³ per filter at 22 L/min, SPARTAN ~7 m³ at 5 L/min). Addis: the same 189 filters as slides 3, 8 and 10. IMPROVE: the calibration pool (n 11,974), volume from the TOR record. Medians 3.9 and 34.1 µg, IMPROVE 99th percentile 28.7 µg. The 15 Oct version of this slide used a cumulative distribution (figures/f4_loading_per_filter.png, still built) that needed too much explaining.</a:t>
             </a:r>
           </a:p>
         </p:txBody>
@@ -1126,7 +1126,7 @@
           <a:p/>
           <a:p>
             <a:r>
-              <a:t>NOTES: EC from HIPS for both networks (IMPROVE fAbs / 10, SPARTAN 'BC PM2.5' = fAbs / 10), so no FTIR EC is used. SPARTAN BC values estimated from the HIPS-SSR curve (method 220) are left out; only HIPS measurements count. Site medians with IQR, log scale; every site, Addis included, uses all its public filters (Addis n 246), so the comparison is like for like across sites. IMPROVE sites with &gt;= 50 filters (FED export, 1988-2025); SPARTAN &gt;= 10 (public release v3.1.4). Addis is number 2 of 242 sites from the top; 17 SPARTAN sites are above the highest IMPROVE site (1.16 µg/m³). Concentration, not per-filter loading: per filter the SPARTAN values would be ~4.6x lower relative to IMPROVE. Table: figures/f5_ec_site_continuum.csv.</a:t>
+              <a:t>NOTES: EC from HIPS for both networks (IMPROVE fAbs / 10, SPARTAN 'BC PM2.5' = fAbs / 10), so no FTIR EC is used. SPARTAN BC values estimated from the HIPS-SSR curve (method 220) are left out; only HIPS measurements count. Site medians with IQR, log scale; every site, Addis included, uses all its public filters (Addis n 246), so the comparison is like for like across sites. IMPROVE sites with &gt;= 50 filters (FED export, 1988-2025); SPARTAN &gt;= 10 (public release v3.1.4). Addis is number 3 of 242 sites from the top; 17 SPARTAN sites are above the highest IMPROVE site (1.16 µg/m³). Concentration, not per-filter loading: per filter the SPARTAN values would be ~4.6x lower relative to IMPROVE. Table: figures/f5_ec_site_continuum.csv.</a:t>
             </a:r>
           </a:p>
         </p:txBody>
@@ -1196,7 +1196,7 @@
           <a:lstStyle/>
           <a:p>
             <a:r>
-              <a:t>SAY: What are we doing about it? The first thing we learned is that the spectra need baseline correction. On the left is the current calibration, without it. On the right, the same Addis filters predicted by a calibration built on baseline-corrected IMPROVE spectra. The intercept moves from -6.1 to -1.2 µg/m³. The slope drops to 0.59, so FTIR now reads low at high EC: better, but not solved.</a:t>
+              <a:t>SAY: What are we doing about it? The first thing we learned is that the spectra need baseline correction. A raw spectrum sits on a sloping, curved background from the filter material and from light scattering; baseline correction fits that background and subtracts it, so only the absorption bands of the particles are left. Point at the axes first: the same as slide 3, HIPS EC along the bottom and FTIR-predicted EC up the side. On the left is the current calibration, without baseline correction. On the right, the same Addis filters predicted by a calibration built on baseline-corrected IMPROVE spectra. The intercept moves from -6.1 to -1.2 µg/m³. The slope drops to 0.59, so FTIR now reads low at high EC: better, but not solved. As before, R² only says the two are related; the slope and intercept are what have to become physically sensible, and the MAC choice moves the slope, not the intercept.</a:t>
             </a:r>
           </a:p>
           <a:p/>
@@ -1272,13 +1272,13 @@
           <a:lstStyle/>
           <a:p>
             <a:r>
-              <a:t>SAY: Next, we built a tool that runs and compares many calibrations. Here are 3,138 of them, all on baseline-corrected spectra, ordered by how far off their Addis intercept is, from worst on the left to best on the right. The top line is that intercept; the current calibration is the red dashed line. Underneath, each row shows which calibrations used a choice: first, which IMPROVE filters to calibrate with, for example filters with the lowest OC/EC, or filters whose spectra look like each Addis season; second, the calibration settings. 3,137 of the 3,138 do better than the current calibration, and 254 get the intercept within half a microgram of zero, though not always with a good slope. We have not found a calibration that gets Addis right yet, but this is how we are searching.</a:t>
+              <a:t>SAY: Next, we built a tool that runs and compares many calibrations. Here are 3,138 of them, all on baseline-corrected spectra, ordered by how far off their Addis intercept is, from worst on the left to best on the right. The top line is that intercept; the current calibration is the red dashed line. Underneath, each row shows which calibrations used a choice: first, which IMPROVE filters to calibrate with, for example filters with the lowest OC/EC, or the IMPROVE spectra that most resemble each Addis season's spectra; second, the calibration settings. 3,137 of the 3,138 do better than the current calibration, and 254 get the intercept within half a microgram of zero, though not always with a good slope. We have not found a calibration that gets Addis right yet, but this is how we are searching.</a:t>
             </a:r>
           </a:p>
           <a:p/>
           <a:p>
             <a:r>
-              <a:t>NOTES: Spline baseline only (the VIBES baseline and no-baseline runs have their own versions of this plot). Deming intercept at MAC 10, median -1.4 µg/m³. Settings rows: cross-validation scheme, number of PLS factors and cohort size; name them if asked, but don't go into them. The explorer scores all 233 Addis filters with HIPS (its stored grid has no per-filter predictions to re-score), while slides 3, 8 and 10 use the 189 that also have a current SPARTAN value. From the gallery export gallery/app/public/data/meeting-r70/spec_curve_20260917.json (rank-70 run).</a:t>
+              <a:t>NOTES: Spline baseline only (the VIBES baseline and no-baseline runs have their own versions of this plot). Deming intercept at MAC 10, median -1.4 µg/m³. Settings rows: cross-validation scheme, number of PLS factors and cohort size; name them if asked, but don't go into them. The explorer scores all 233 Addis filters with HIPS (its stored grid has no per-filter predictions to re-score), while slides 3, 8 and 10 use the 189 that also have a current SPARTAN value. From the gallery export gallery/app/public/data/meeting-r70/spec_curve_20260917.json (rank-70 run). Selection rows: 'Spectral analogs' = the IMPROVE spectra with the highest correlation to the Addis (or one season's) median spectrum across wavenumbers, excluding defined regions such as the CO₂ band; 'weighted distance' ranks by a distance that weights wavenumbers by their importance in the PLS model; 'Smoke filters nearest Addis in C-H/carbonyl bands' (called 'Ethiopia-shaped smoke' in the explorer) = IMPROVE smoke-affected filters ranked by how close three band heights (C-H, carbonyl, 1600 cm⁻¹ shoulder) are to the Addis median.</a:t>
             </a:r>
           </a:p>
         </p:txBody>
@@ -4487,7 +4487,7 @@
         <p:spPr>
           <a:xfrm>
             <a:off x="518007" y="1143000"/>
-            <a:ext cx="11155680" cy="4139465"/>
+            <a:ext cx="11155680" cy="4133804"/>
           </a:xfrm>
           <a:prstGeom prst="rect">
             <a:avLst/>
@@ -4595,7 +4595,7 @@
               </a:defRPr>
             </a:pPr>
             <a:r>
-              <a:t>Current FTIR calibrations poorly predict Addis EC, and also IMPROVE filters with Addis-like spectra.</a:t>
+              <a:t>Current FTIR calibrations poorly predict Addis EC, and also the IMPROVE filters whose spectra most resemble Addis.</a:t>
             </a:r>
           </a:p>
           <a:p>
@@ -4714,8 +4714,8 @@
         </p:blipFill>
         <p:spPr>
           <a:xfrm>
-            <a:off x="1130583" y="1143000"/>
-            <a:ext cx="9930528" cy="5486400"/>
+            <a:off x="518007" y="1143000"/>
+            <a:ext cx="11155680" cy="4791925"/>
           </a:xfrm>
           <a:prstGeom prst="rect">
             <a:avLst/>
@@ -4791,8 +4791,8 @@
         </p:blipFill>
         <p:spPr>
           <a:xfrm>
-            <a:off x="2952463" y="1143000"/>
-            <a:ext cx="6286768" cy="5486400"/>
+            <a:off x="2849189" y="1143000"/>
+            <a:ext cx="6493315" cy="5486400"/>
           </a:xfrm>
           <a:prstGeom prst="rect">
             <a:avLst/>
@@ -5008,7 +5008,7 @@
       </p:sp>
       <p:pic>
         <p:nvPicPr>
-          <p:cNvPr id="3" name="Picture 2" descr="f4_loading_per_filter.png"/>
+          <p:cNvPr id="3" name="Picture 2" descr="f4b_loading_per_filter_hist.png"/>
           <p:cNvPicPr>
             <a:picLocks noChangeAspect="1"/>
           </p:cNvPicPr>
@@ -5023,7 +5023,7 @@
         <p:spPr>
           <a:xfrm>
             <a:off x="518007" y="1143000"/>
-            <a:ext cx="11155680" cy="4933443"/>
+            <a:ext cx="11155680" cy="5394599"/>
           </a:xfrm>
           <a:prstGeom prst="rect">
             <a:avLst/>
@@ -5254,7 +5254,7 @@
         <p:spPr>
           <a:xfrm>
             <a:off x="518007" y="1143000"/>
-            <a:ext cx="11155680" cy="4880295"/>
+            <a:ext cx="11155680" cy="4487278"/>
           </a:xfrm>
           <a:prstGeom prst="rect">
             <a:avLst/>

</xml_diff>